<commit_message>
Updated slides for lecture 5.2 by adding RMSNorm
</commit_message>
<xml_diff>
--- a/Module 5/class_5.2/deep_learning_course_class_5.2.pptx
+++ b/Module 5/class_5.2/deep_learning_course_class_5.2.pptx
@@ -26,16 +26,18 @@
     <p:sldId id="271" r:id="rId21"/>
     <p:sldId id="272" r:id="rId22"/>
     <p:sldId id="273" r:id="rId23"/>
+    <p:sldId id="274" r:id="rId24"/>
+    <p:sldId id="275" r:id="rId25"/>
   </p:sldIdLst>
   <p:sldSz cy="5143500" cx="9144000"/>
   <p:notesSz cx="6858000" cy="9144000"/>
   <p:embeddedFontLst>
     <p:embeddedFont>
       <p:font typeface="Roboto Mono"/>
-      <p:regular r:id="rId24"/>
-      <p:bold r:id="rId25"/>
-      <p:italic r:id="rId26"/>
-      <p:boldItalic r:id="rId27"/>
+      <p:regular r:id="rId26"/>
+      <p:bold r:id="rId27"/>
+      <p:italic r:id="rId28"/>
+      <p:boldItalic r:id="rId29"/>
     </p:embeddedFont>
   </p:embeddedFontLst>
   <p:defaultTextStyle>
@@ -1523,7 +1525,7 @@
       </p:grpSpPr>
       <p:sp>
         <p:nvSpPr>
-          <p:cNvPr id="206" name="Google Shape;206;g3957f4c9d0f_0_0:notes"/>
+          <p:cNvPr id="206" name="Google Shape;206;g395cb806990_0_15:notes"/>
           <p:cNvSpPr/>
           <p:nvPr>
             <p:ph idx="2" type="sldImg"/>
@@ -1558,7 +1560,7 @@
       </p:sp>
       <p:sp>
         <p:nvSpPr>
-          <p:cNvPr id="207" name="Google Shape;207;g3957f4c9d0f_0_0:notes"/>
+          <p:cNvPr id="207" name="Google Shape;207;g395cb806990_0_15:notes"/>
           <p:cNvSpPr txBox="1"/>
           <p:nvPr>
             <p:ph idx="1" type="body"/>
@@ -1608,7 +1610,7 @@
   <p:cSld>
     <p:spTree>
       <p:nvGrpSpPr>
-        <p:cNvPr id="211" name="Shape 211"/>
+        <p:cNvPr id="212" name="Shape 212"/>
         <p:cNvGrpSpPr/>
         <p:nvPr/>
       </p:nvGrpSpPr>
@@ -1622,7 +1624,7 @@
       </p:grpSpPr>
       <p:sp>
         <p:nvSpPr>
-          <p:cNvPr id="212" name="Google Shape;212;g3957f86a122_1_12:notes"/>
+          <p:cNvPr id="213" name="Google Shape;213;g395cb806990_0_22:notes"/>
           <p:cNvSpPr/>
           <p:nvPr>
             <p:ph idx="2" type="sldImg"/>
@@ -1657,7 +1659,106 @@
       </p:sp>
       <p:sp>
         <p:nvSpPr>
-          <p:cNvPr id="213" name="Google Shape;213;g3957f86a122_1_12:notes"/>
+          <p:cNvPr id="214" name="Google Shape;214;g395cb806990_0_22:notes"/>
+          <p:cNvSpPr txBox="1"/>
+          <p:nvPr>
+            <p:ph idx="1" type="body"/>
+          </p:nvPr>
+        </p:nvSpPr>
+        <p:spPr>
+          <a:xfrm>
+            <a:off x="685800" y="4343400"/>
+            <a:ext cx="5486400" cy="4114800"/>
+          </a:xfrm>
+          <a:prstGeom prst="rect">
+            <a:avLst/>
+          </a:prstGeom>
+        </p:spPr>
+        <p:txBody>
+          <a:bodyPr anchorCtr="0" anchor="t" bIns="91425" lIns="91425" spcFirstLastPara="1" rIns="91425" wrap="square" tIns="91425">
+            <a:noAutofit/>
+          </a:bodyPr>
+          <a:lstStyle/>
+          <a:p>
+            <a:pPr indent="0" lvl="0" marL="0" rtl="0" algn="l">
+              <a:spcBef>
+                <a:spcPts val="0"/>
+              </a:spcBef>
+              <a:spcAft>
+                <a:spcPts val="0"/>
+              </a:spcAft>
+              <a:buNone/>
+            </a:pPr>
+            <a:r>
+              <a:t/>
+            </a:r>
+            <a:endParaRPr/>
+          </a:p>
+        </p:txBody>
+      </p:sp>
+    </p:spTree>
+  </p:cSld>
+  <p:clrMapOvr>
+    <a:masterClrMapping/>
+  </p:clrMapOvr>
+</p:notes>
+</file>
+
+<file path=ppt/notesSlides/notesSlide19.xml><?xml version="1.0" encoding="utf-8"?>
+<p:notes xmlns:a="http://schemas.openxmlformats.org/drawingml/2006/main" xmlns:r="http://schemas.openxmlformats.org/officeDocument/2006/relationships" xmlns:mc="http://schemas.openxmlformats.org/markup-compatibility/2006" xmlns:mv="urn:schemas-microsoft-com:mac:vml" xmlns:p="http://schemas.openxmlformats.org/presentationml/2006/main" xmlns:c="http://schemas.openxmlformats.org/drawingml/2006/chart" xmlns:dgm="http://schemas.openxmlformats.org/drawingml/2006/diagram" xmlns:o="urn:schemas-microsoft-com:office:office" xmlns:v="urn:schemas-microsoft-com:vml" xmlns:pvml="urn:schemas-microsoft-com:office:powerpoint" xmlns:com="http://schemas.openxmlformats.org/drawingml/2006/compatibility" xmlns:p14="http://schemas.microsoft.com/office/powerpoint/2010/main" xmlns:p15="http://schemas.microsoft.com/office/powerpoint/2012/main" xmlns:ahyp="http://schemas.microsoft.com/office/drawing/2018/hyperlinkcolor" showMasterPhAnim="0" showMasterSp="0">
+  <p:cSld>
+    <p:spTree>
+      <p:nvGrpSpPr>
+        <p:cNvPr id="219" name="Shape 219"/>
+        <p:cNvGrpSpPr/>
+        <p:nvPr/>
+      </p:nvGrpSpPr>
+      <p:grpSpPr>
+        <a:xfrm>
+          <a:off x="0" y="0"/>
+          <a:ext cx="0" cy="0"/>
+          <a:chOff x="0" y="0"/>
+          <a:chExt cx="0" cy="0"/>
+        </a:xfrm>
+      </p:grpSpPr>
+      <p:sp>
+        <p:nvSpPr>
+          <p:cNvPr id="220" name="Google Shape;220;g3957f4c9d0f_0_0:notes"/>
+          <p:cNvSpPr/>
+          <p:nvPr>
+            <p:ph idx="2" type="sldImg"/>
+          </p:nvPr>
+        </p:nvSpPr>
+        <p:spPr>
+          <a:xfrm>
+            <a:off x="381300" y="685800"/>
+            <a:ext cx="6096000" cy="3429000"/>
+          </a:xfrm>
+          <a:custGeom>
+            <a:rect b="b" l="l" r="r" t="t"/>
+            <a:pathLst>
+              <a:path extrusionOk="0" h="120000" w="120000">
+                <a:moveTo>
+                  <a:pt x="0" y="0"/>
+                </a:moveTo>
+                <a:lnTo>
+                  <a:pt x="120000" y="0"/>
+                </a:lnTo>
+                <a:lnTo>
+                  <a:pt x="120000" y="120000"/>
+                </a:lnTo>
+                <a:lnTo>
+                  <a:pt x="0" y="120000"/>
+                </a:lnTo>
+                <a:close/>
+              </a:path>
+            </a:pathLst>
+          </a:custGeom>
+        </p:spPr>
+      </p:sp>
+      <p:sp>
+        <p:nvSpPr>
+          <p:cNvPr id="221" name="Google Shape;221;g3957f4c9d0f_0_0:notes"/>
           <p:cNvSpPr txBox="1"/>
           <p:nvPr>
             <p:ph idx="1" type="body"/>
@@ -1757,6 +1858,105 @@
       <p:sp>
         <p:nvSpPr>
           <p:cNvPr id="58" name="Google Shape;58;g3c887823e2c_0_0:notes"/>
+          <p:cNvSpPr txBox="1"/>
+          <p:nvPr>
+            <p:ph idx="1" type="body"/>
+          </p:nvPr>
+        </p:nvSpPr>
+        <p:spPr>
+          <a:xfrm>
+            <a:off x="685800" y="4343400"/>
+            <a:ext cx="5486400" cy="4114800"/>
+          </a:xfrm>
+          <a:prstGeom prst="rect">
+            <a:avLst/>
+          </a:prstGeom>
+        </p:spPr>
+        <p:txBody>
+          <a:bodyPr anchorCtr="0" anchor="t" bIns="91425" lIns="91425" spcFirstLastPara="1" rIns="91425" wrap="square" tIns="91425">
+            <a:noAutofit/>
+          </a:bodyPr>
+          <a:lstStyle/>
+          <a:p>
+            <a:pPr indent="0" lvl="0" marL="0" rtl="0" algn="l">
+              <a:spcBef>
+                <a:spcPts val="0"/>
+              </a:spcBef>
+              <a:spcAft>
+                <a:spcPts val="0"/>
+              </a:spcAft>
+              <a:buNone/>
+            </a:pPr>
+            <a:r>
+              <a:t/>
+            </a:r>
+            <a:endParaRPr/>
+          </a:p>
+        </p:txBody>
+      </p:sp>
+    </p:spTree>
+  </p:cSld>
+  <p:clrMapOvr>
+    <a:masterClrMapping/>
+  </p:clrMapOvr>
+</p:notes>
+</file>
+
+<file path=ppt/notesSlides/notesSlide20.xml><?xml version="1.0" encoding="utf-8"?>
+<p:notes xmlns:a="http://schemas.openxmlformats.org/drawingml/2006/main" xmlns:r="http://schemas.openxmlformats.org/officeDocument/2006/relationships" xmlns:mc="http://schemas.openxmlformats.org/markup-compatibility/2006" xmlns:mv="urn:schemas-microsoft-com:mac:vml" xmlns:p="http://schemas.openxmlformats.org/presentationml/2006/main" xmlns:c="http://schemas.openxmlformats.org/drawingml/2006/chart" xmlns:dgm="http://schemas.openxmlformats.org/drawingml/2006/diagram" xmlns:o="urn:schemas-microsoft-com:office:office" xmlns:v="urn:schemas-microsoft-com:vml" xmlns:pvml="urn:schemas-microsoft-com:office:powerpoint" xmlns:com="http://schemas.openxmlformats.org/drawingml/2006/compatibility" xmlns:p14="http://schemas.microsoft.com/office/powerpoint/2010/main" xmlns:p15="http://schemas.microsoft.com/office/powerpoint/2012/main" xmlns:ahyp="http://schemas.microsoft.com/office/drawing/2018/hyperlinkcolor" showMasterPhAnim="0" showMasterSp="0">
+  <p:cSld>
+    <p:spTree>
+      <p:nvGrpSpPr>
+        <p:cNvPr id="225" name="Shape 225"/>
+        <p:cNvGrpSpPr/>
+        <p:nvPr/>
+      </p:nvGrpSpPr>
+      <p:grpSpPr>
+        <a:xfrm>
+          <a:off x="0" y="0"/>
+          <a:ext cx="0" cy="0"/>
+          <a:chOff x="0" y="0"/>
+          <a:chExt cx="0" cy="0"/>
+        </a:xfrm>
+      </p:grpSpPr>
+      <p:sp>
+        <p:nvSpPr>
+          <p:cNvPr id="226" name="Google Shape;226;g3957f86a122_1_12:notes"/>
+          <p:cNvSpPr/>
+          <p:nvPr>
+            <p:ph idx="2" type="sldImg"/>
+          </p:nvPr>
+        </p:nvSpPr>
+        <p:spPr>
+          <a:xfrm>
+            <a:off x="381300" y="685800"/>
+            <a:ext cx="6096000" cy="3429000"/>
+          </a:xfrm>
+          <a:custGeom>
+            <a:rect b="b" l="l" r="r" t="t"/>
+            <a:pathLst>
+              <a:path extrusionOk="0" h="120000" w="120000">
+                <a:moveTo>
+                  <a:pt x="0" y="0"/>
+                </a:moveTo>
+                <a:lnTo>
+                  <a:pt x="120000" y="0"/>
+                </a:lnTo>
+                <a:lnTo>
+                  <a:pt x="120000" y="120000"/>
+                </a:lnTo>
+                <a:lnTo>
+                  <a:pt x="0" y="120000"/>
+                </a:lnTo>
+                <a:close/>
+              </a:path>
+            </a:pathLst>
+          </a:custGeom>
+        </p:spPr>
+      </p:sp>
+      <p:sp>
+        <p:nvSpPr>
+          <p:cNvPr id="227" name="Google Shape;227;g3957f86a122_1_12:notes"/>
           <p:cNvSpPr txBox="1"/>
           <p:nvPr>
             <p:ph idx="1" type="body"/>
@@ -9720,7 +9920,7 @@
             </a:pPr>
             <a:r>
               <a:rPr lang="en"/>
-              <a:t>Common tricks..</a:t>
+              <a:t>RMS Normalization (RMSNorm)	</a:t>
             </a:r>
             <a:endParaRPr/>
           </a:p>
@@ -9737,7 +9937,7 @@
         <p:spPr>
           <a:xfrm>
             <a:off x="311700" y="1152475"/>
-            <a:ext cx="8520600" cy="3416400"/>
+            <a:ext cx="8520600" cy="990300"/>
           </a:xfrm>
           <a:prstGeom prst="rect">
             <a:avLst/>
@@ -9749,91 +9949,51 @@
           </a:bodyPr>
           <a:lstStyle/>
           <a:p>
-            <a:pPr indent="-342900" lvl="0" marL="457200" rtl="0" algn="l">
-              <a:spcBef>
-                <a:spcPts val="0"/>
-              </a:spcBef>
-              <a:spcAft>
-                <a:spcPts val="0"/>
-              </a:spcAft>
-              <a:buSzPts val="1800"/>
-              <a:buChar char="-"/>
+            <a:pPr indent="0" lvl="0" marL="0" rtl="0" algn="l">
+              <a:spcBef>
+                <a:spcPts val="0"/>
+              </a:spcBef>
+              <a:spcAft>
+                <a:spcPts val="1200"/>
+              </a:spcAft>
+              <a:buNone/>
             </a:pPr>
             <a:r>
               <a:rPr lang="en"/>
-              <a:t>Data augmentation</a:t>
-            </a:r>
-            <a:endParaRPr/>
-          </a:p>
-          <a:p>
-            <a:pPr indent="-342900" lvl="0" marL="457200" rtl="0" algn="l">
-              <a:spcBef>
-                <a:spcPts val="0"/>
-              </a:spcBef>
-              <a:spcAft>
-                <a:spcPts val="0"/>
-              </a:spcAft>
-              <a:buSzPts val="1800"/>
-              <a:buChar char="-"/>
-            </a:pPr>
-            <a:r>
-              <a:rPr lang="en"/>
-              <a:t>Setting up a convolutional network with downsampling points (using striding) accompanied by increase in channels</a:t>
-            </a:r>
-            <a:endParaRPr/>
-          </a:p>
-          <a:p>
-            <a:pPr indent="-342900" lvl="0" marL="457200" rtl="0" algn="l">
-              <a:spcBef>
-                <a:spcPts val="0"/>
-              </a:spcBef>
-              <a:spcAft>
-                <a:spcPts val="0"/>
-              </a:spcAft>
-              <a:buSzPts val="1800"/>
-              <a:buChar char="-"/>
-            </a:pPr>
-            <a:r>
-              <a:rPr lang="en"/>
-              <a:t>In the </a:t>
-            </a:r>
-            <a:r>
-              <a:rPr lang="en"/>
-              <a:t>batch</a:t>
-            </a:r>
-            <a:r>
-              <a:rPr lang="en"/>
-              <a:t> normalization + residual connection implementation, using the concept of blocks. Each block has several convolutional layers. First convolutional layer halves the spatial dimension and doubles the number of channels.</a:t>
-            </a:r>
-            <a:endParaRPr/>
-          </a:p>
-          <a:p>
-            <a:pPr indent="-342900" lvl="0" marL="457200" rtl="0" algn="l">
-              <a:spcBef>
-                <a:spcPts val="0"/>
-              </a:spcBef>
-              <a:spcAft>
-                <a:spcPts val="0"/>
-              </a:spcAft>
-              <a:buSzPts val="1800"/>
-              <a:buChar char="-"/>
-            </a:pPr>
-            <a:r>
-              <a:rPr lang="en"/>
-              <a:t>In the </a:t>
-            </a:r>
-            <a:r>
-              <a:rPr lang="en"/>
-              <a:t>residual</a:t>
-            </a:r>
-            <a:r>
-              <a:rPr lang="en"/>
-              <a:t> connection, add a 1d conv if spatial dimension change</a:t>
+              <a:t>Modern transformers use a simpler version of Layernorm called RMSNorm. RMSNorm removes the centering by the mean..</a:t>
             </a:r>
             <a:endParaRPr/>
           </a:p>
         </p:txBody>
       </p:sp>
+      <p:pic>
+        <p:nvPicPr>
+          <p:cNvPr descr="{&quot;backgroundColorModified&quot;:false,&quot;id&quot;:&quot;7&quot;,&quot;font&quot;:{&quot;family&quot;:&quot;Arial&quot;,&quot;size&quot;:12,&quot;color&quot;:&quot;#000000&quot;},&quot;backgroundColor&quot;:&quot;#FFFFFF&quot;,&quot;code&quot;:&quot;\\begin{gather*}\n{\\text{For}\\;\\text{eac}\\text{h}\\;\\text{sample}\\;x_{b}\\,\\text{(a}\\;\\text{D}\\;\\text{dimensional}\\;\\text{vector)}\\;\\text{in}\\;\\text{a}\\;\\text{batch}\\;\\text{of}\\;\\text{size}\\;\\text{B,}\\text{}}\\\\\n{\\sigma_{b}^{2}=\\frac{1}{D}\\sum_{i=1}^{D}\\left(x_{bi}\\right)^{2}}\\\\\n{r_{b}={\\sqrt[]{\\sigma_{b}^{2}+\\epsilon}}}\\\\\n{r_{b}:\\,\\text{RMSNorm}}\\\\\n{\\text{Normalized}\\;\\text{coordinates:}}\\\\\n{y_{bi}=\\lambda_{i}\\frac{x_{bi}}{r_{b}}}\t\n\\end{gather*}&quot;,&quot;aid&quot;:null,&quot;type&quot;:&quot;gather*&quot;,&quot;ts&quot;:1772896681877,&quot;cs&quot;:&quot;FeyBFSYuQ2EzGsbq37ILKA==&quot;,&quot;size&quot;:{&quot;width&quot;:524.5,&quot;height&quot;:212.5}}" id="211" name="Google Shape;211;p29"/>
+          <p:cNvPicPr preferRelativeResize="0"/>
+          <p:nvPr/>
+        </p:nvPicPr>
+        <p:blipFill>
+          <a:blip r:embed="rId3">
+            <a:alphaModFix/>
+          </a:blip>
+          <a:stretch>
+            <a:fillRect/>
+          </a:stretch>
+        </p:blipFill>
+        <p:spPr>
+          <a:xfrm>
+            <a:off x="417879" y="2277519"/>
+            <a:ext cx="4995863" cy="2024063"/>
+          </a:xfrm>
+          <a:prstGeom prst="rect">
+            <a:avLst/>
+          </a:prstGeom>
+          <a:noFill/>
+          <a:ln>
+            <a:noFill/>
+          </a:ln>
+        </p:spPr>
+      </p:pic>
     </p:spTree>
   </p:cSld>
   <p:clrMapOvr>
@@ -9847,7 +10007,7 @@
   <p:cSld>
     <p:spTree>
       <p:nvGrpSpPr>
-        <p:cNvPr id="214" name="Shape 214"/>
+        <p:cNvPr id="215" name="Shape 215"/>
         <p:cNvGrpSpPr/>
         <p:nvPr/>
       </p:nvGrpSpPr>
@@ -9861,7 +10021,7 @@
       </p:grpSpPr>
       <p:sp>
         <p:nvSpPr>
-          <p:cNvPr id="215" name="Google Shape;215;p30"/>
+          <p:cNvPr id="216" name="Google Shape;216;p30"/>
           <p:cNvSpPr txBox="1"/>
           <p:nvPr>
             <p:ph type="title"/>
@@ -9893,15 +10053,7 @@
             </a:pPr>
             <a:r>
               <a:rPr lang="en"/>
-              <a:t>Using lower precision data types in the </a:t>
-            </a:r>
-            <a:r>
-              <a:rPr lang="en"/>
-              <a:t>training</a:t>
-            </a:r>
-            <a:r>
-              <a:rPr lang="en"/>
-              <a:t> loop</a:t>
+              <a:t>RMSNorm: Backprop</a:t>
             </a:r>
             <a:endParaRPr/>
           </a:p>
@@ -9909,26 +10061,24 @@
       </p:sp>
       <p:sp>
         <p:nvSpPr>
-          <p:cNvPr id="216" name="Google Shape;216;p30"/>
+          <p:cNvPr id="217" name="Google Shape;217;p30"/>
           <p:cNvSpPr txBox="1"/>
-          <p:nvPr/>
-        </p:nvSpPr>
-        <p:spPr>
-          <a:xfrm>
-            <a:off x="5454900" y="1156275"/>
-            <a:ext cx="3585600" cy="600300"/>
+          <p:nvPr>
+            <p:ph idx="1" type="body"/>
+          </p:nvPr>
+        </p:nvSpPr>
+        <p:spPr>
+          <a:xfrm>
+            <a:off x="311700" y="1152475"/>
+            <a:ext cx="2361600" cy="532800"/>
           </a:xfrm>
           <a:prstGeom prst="rect">
             <a:avLst/>
           </a:prstGeom>
-          <a:noFill/>
-          <a:ln>
-            <a:noFill/>
-          </a:ln>
         </p:spPr>
         <p:txBody>
           <a:bodyPr anchorCtr="0" anchor="t" bIns="91425" lIns="91425" spcFirstLastPara="1" rIns="91425" wrap="square" tIns="91425">
-            <a:spAutoFit/>
+            <a:normAutofit fontScale="62500" lnSpcReduction="20000"/>
           </a:bodyPr>
           <a:lstStyle/>
           <a:p>
@@ -9937,431 +10087,21 @@
                 <a:spcPts val="0"/>
               </a:spcBef>
               <a:spcAft>
-                <a:spcPts val="0"/>
+                <a:spcPts val="1200"/>
               </a:spcAft>
               <a:buNone/>
             </a:pPr>
             <a:r>
-              <a:rPr lang="en" sz="900">
-                <a:solidFill>
-                  <a:schemeClr val="dk1"/>
-                </a:solidFill>
-              </a:rPr>
-              <a:t>A</a:t>
-            </a:r>
-            <a:r>
-              <a:rPr lang="en" sz="900">
-                <a:solidFill>
-                  <a:schemeClr val="dk1"/>
-                </a:solidFill>
-              </a:rPr>
-              <a:t>ffects </a:t>
-            </a:r>
-            <a:r>
-              <a:rPr b="1" lang="en" sz="900">
-                <a:solidFill>
-                  <a:schemeClr val="dk1"/>
-                </a:solidFill>
-              </a:rPr>
-              <a:t>ops executed inside the context</a:t>
-            </a:r>
-            <a:r>
-              <a:rPr lang="en" sz="900">
-                <a:solidFill>
-                  <a:schemeClr val="dk1"/>
-                </a:solidFill>
-              </a:rPr>
-              <a:t> by choosing a “fast” dtype for each op (fp16/bf16 for many GEMMs/convs, fp32 for numerically sensitive ops like some reductions/softmax parts, etc.)</a:t>
-            </a:r>
-            <a:endParaRPr sz="1200"/>
+              <a:rPr lang="en"/>
+              <a:t>The derivative of loss against lambda is identical to Layernorm.</a:t>
+            </a:r>
+            <a:endParaRPr/>
           </a:p>
         </p:txBody>
       </p:sp>
-      <p:sp>
-        <p:nvSpPr>
-          <p:cNvPr id="217" name="Google Shape;217;p30"/>
-          <p:cNvSpPr txBox="1"/>
-          <p:nvPr/>
-        </p:nvSpPr>
-        <p:spPr>
-          <a:xfrm>
-            <a:off x="5557800" y="1978100"/>
-            <a:ext cx="3379800" cy="1262100"/>
-          </a:xfrm>
-          <a:prstGeom prst="rect">
-            <a:avLst/>
-          </a:prstGeom>
-          <a:noFill/>
-          <a:ln>
-            <a:noFill/>
-          </a:ln>
-        </p:spPr>
-        <p:txBody>
-          <a:bodyPr anchorCtr="0" anchor="t" bIns="91425" lIns="91425" spcFirstLastPara="1" rIns="91425" wrap="square" tIns="91425">
-            <a:spAutoFit/>
-          </a:bodyPr>
-          <a:lstStyle/>
-          <a:p>
-            <a:pPr indent="0" lvl="0" marL="0" rtl="0" algn="l">
-              <a:spcBef>
-                <a:spcPts val="0"/>
-              </a:spcBef>
-              <a:spcAft>
-                <a:spcPts val="0"/>
-              </a:spcAft>
-              <a:buNone/>
-            </a:pPr>
-            <a:r>
-              <a:rPr lang="en" sz="1000">
-                <a:solidFill>
-                  <a:schemeClr val="dk1"/>
-                </a:solidFill>
-              </a:rPr>
-              <a:t>If we computed gradients also in a lower dtype (eg., fp16), small gradients might underflow to 0. So, we scale up the loss and then calculate the gradients. This way gradient flow is preserved. Also, gradients often sum many contributions. In low precision, when you add a tiny number to a running total, the tiny increment can get rounded away. </a:t>
-            </a:r>
-            <a:endParaRPr sz="1300"/>
-          </a:p>
-        </p:txBody>
-      </p:sp>
-      <p:sp>
-        <p:nvSpPr>
-          <p:cNvPr id="218" name="Google Shape;218;p30"/>
-          <p:cNvSpPr txBox="1"/>
-          <p:nvPr/>
-        </p:nvSpPr>
-        <p:spPr>
-          <a:xfrm>
-            <a:off x="97975" y="1177700"/>
-            <a:ext cx="2916900" cy="800400"/>
-          </a:xfrm>
-          <a:prstGeom prst="rect">
-            <a:avLst/>
-          </a:prstGeom>
-          <a:noFill/>
-          <a:ln>
-            <a:noFill/>
-          </a:ln>
-        </p:spPr>
-        <p:txBody>
-          <a:bodyPr anchorCtr="0" anchor="t" bIns="91425" lIns="91425" spcFirstLastPara="1" rIns="91425" wrap="square" tIns="91425">
-            <a:spAutoFit/>
-          </a:bodyPr>
-          <a:lstStyle/>
-          <a:p>
-            <a:pPr indent="0" lvl="0" marL="0" rtl="0" algn="l">
-              <a:spcBef>
-                <a:spcPts val="0"/>
-              </a:spcBef>
-              <a:spcAft>
-                <a:spcPts val="0"/>
-              </a:spcAft>
-              <a:buNone/>
-            </a:pPr>
-            <a:r>
-              <a:rPr lang="en" sz="1000">
-                <a:solidFill>
-                  <a:schemeClr val="dk1"/>
-                </a:solidFill>
-              </a:rPr>
-              <a:t>Once the gradients have been calculated, we scale them back to the original scale. Generally gradients are represented in full precision at this step, so underflow isn’t an issue </a:t>
-            </a:r>
-            <a:endParaRPr sz="1300"/>
-          </a:p>
-        </p:txBody>
-      </p:sp>
-      <p:sp>
-        <p:nvSpPr>
-          <p:cNvPr id="219" name="Google Shape;219;p30"/>
-          <p:cNvSpPr txBox="1"/>
-          <p:nvPr/>
-        </p:nvSpPr>
-        <p:spPr>
-          <a:xfrm>
-            <a:off x="235500" y="3945225"/>
-            <a:ext cx="3000000" cy="461700"/>
-          </a:xfrm>
-          <a:prstGeom prst="rect">
-            <a:avLst/>
-          </a:prstGeom>
-          <a:noFill/>
-          <a:ln>
-            <a:noFill/>
-          </a:ln>
-        </p:spPr>
-        <p:txBody>
-          <a:bodyPr anchorCtr="0" anchor="t" bIns="91425" lIns="91425" spcFirstLastPara="1" rIns="91425" wrap="square" tIns="91425">
-            <a:spAutoFit/>
-          </a:bodyPr>
-          <a:lstStyle/>
-          <a:p>
-            <a:pPr indent="0" lvl="0" marL="0" rtl="0" algn="l">
-              <a:spcBef>
-                <a:spcPts val="0"/>
-              </a:spcBef>
-              <a:spcAft>
-                <a:spcPts val="0"/>
-              </a:spcAft>
-              <a:buNone/>
-            </a:pPr>
-            <a:r>
-              <a:rPr lang="en" sz="900">
-                <a:solidFill>
-                  <a:schemeClr val="dk1"/>
-                </a:solidFill>
-              </a:rPr>
-              <a:t>checks if any grads are inf/nan. If yes, it </a:t>
-            </a:r>
-            <a:r>
-              <a:rPr b="1" lang="en" sz="900">
-                <a:solidFill>
-                  <a:schemeClr val="dk1"/>
-                </a:solidFill>
-              </a:rPr>
-              <a:t>skips</a:t>
-            </a:r>
-            <a:r>
-              <a:rPr lang="en" sz="900">
-                <a:solidFill>
-                  <a:schemeClr val="dk1"/>
-                </a:solidFill>
-              </a:rPr>
-              <a:t> </a:t>
-            </a:r>
-            <a:r>
-              <a:rPr lang="en" sz="900">
-                <a:solidFill>
-                  <a:schemeClr val="dk1"/>
-                </a:solidFill>
-              </a:rPr>
-              <a:t>optimizer.step().</a:t>
-            </a:r>
-            <a:endParaRPr sz="900">
-              <a:solidFill>
-                <a:schemeClr val="dk1"/>
-              </a:solidFill>
-            </a:endParaRPr>
-          </a:p>
-        </p:txBody>
-      </p:sp>
-      <p:sp>
-        <p:nvSpPr>
-          <p:cNvPr id="220" name="Google Shape;220;p30"/>
-          <p:cNvSpPr txBox="1"/>
-          <p:nvPr/>
-        </p:nvSpPr>
-        <p:spPr>
-          <a:xfrm>
-            <a:off x="3323700" y="4200575"/>
-            <a:ext cx="2496600" cy="492600"/>
-          </a:xfrm>
-          <a:prstGeom prst="rect">
-            <a:avLst/>
-          </a:prstGeom>
-          <a:noFill/>
-          <a:ln>
-            <a:noFill/>
-          </a:ln>
-        </p:spPr>
-        <p:txBody>
-          <a:bodyPr anchorCtr="0" anchor="t" bIns="91425" lIns="91425" spcFirstLastPara="1" rIns="91425" wrap="square" tIns="91425">
-            <a:spAutoFit/>
-          </a:bodyPr>
-          <a:lstStyle/>
-          <a:p>
-            <a:pPr indent="0" lvl="0" marL="0" rtl="0" algn="l">
-              <a:spcBef>
-                <a:spcPts val="0"/>
-              </a:spcBef>
-              <a:spcAft>
-                <a:spcPts val="0"/>
-              </a:spcAft>
-              <a:buNone/>
-            </a:pPr>
-            <a:r>
-              <a:rPr lang="en" sz="1000">
-                <a:solidFill>
-                  <a:schemeClr val="dk1"/>
-                </a:solidFill>
-              </a:rPr>
-              <a:t>A</a:t>
-            </a:r>
-            <a:r>
-              <a:rPr lang="en" sz="1000">
-                <a:solidFill>
-                  <a:schemeClr val="dk1"/>
-                </a:solidFill>
-              </a:rPr>
-              <a:t>djusts </a:t>
-            </a:r>
-            <a:r>
-              <a:rPr lang="en" sz="1000">
-                <a:solidFill>
-                  <a:srgbClr val="188038"/>
-                </a:solidFill>
-                <a:latin typeface="Roboto Mono"/>
-                <a:ea typeface="Roboto Mono"/>
-                <a:cs typeface="Roboto Mono"/>
-                <a:sym typeface="Roboto Mono"/>
-              </a:rPr>
-              <a:t>S</a:t>
-            </a:r>
-            <a:r>
-              <a:rPr lang="en" sz="1000">
-                <a:solidFill>
-                  <a:schemeClr val="dk1"/>
-                </a:solidFill>
-              </a:rPr>
-              <a:t> (down if overflow happened; up slowly if things are stable)</a:t>
-            </a:r>
-            <a:endParaRPr sz="1300"/>
-          </a:p>
-        </p:txBody>
-      </p:sp>
-      <p:sp>
-        <p:nvSpPr>
-          <p:cNvPr id="221" name="Google Shape;221;p30"/>
-          <p:cNvSpPr txBox="1"/>
-          <p:nvPr/>
-        </p:nvSpPr>
-        <p:spPr>
-          <a:xfrm>
-            <a:off x="0" y="2220850"/>
-            <a:ext cx="2396400" cy="1339200"/>
-          </a:xfrm>
-          <a:prstGeom prst="rect">
-            <a:avLst/>
-          </a:prstGeom>
-          <a:noFill/>
-          <a:ln>
-            <a:noFill/>
-          </a:ln>
-        </p:spPr>
-        <p:txBody>
-          <a:bodyPr anchorCtr="0" anchor="t" bIns="91425" lIns="91425" spcFirstLastPara="1" rIns="91425" wrap="square" tIns="91425">
-            <a:spAutoFit/>
-          </a:bodyPr>
-          <a:lstStyle/>
-          <a:p>
-            <a:pPr indent="0" lvl="0" marL="0" rtl="0" algn="l">
-              <a:spcBef>
-                <a:spcPts val="0"/>
-              </a:spcBef>
-              <a:spcAft>
-                <a:spcPts val="0"/>
-              </a:spcAft>
-              <a:buNone/>
-            </a:pPr>
-            <a:r>
-              <a:rPr lang="en" sz="900">
-                <a:solidFill>
-                  <a:schemeClr val="dk1"/>
-                </a:solidFill>
-              </a:rPr>
-              <a:t>It looks at </a:t>
-            </a:r>
-            <a:r>
-              <a:rPr b="1" lang="en" sz="900">
-                <a:solidFill>
-                  <a:schemeClr val="dk1"/>
-                </a:solidFill>
-              </a:rPr>
-              <a:t>all gradients together</a:t>
-            </a:r>
-            <a:r>
-              <a:rPr lang="en" sz="900">
-                <a:solidFill>
-                  <a:schemeClr val="dk1"/>
-                </a:solidFill>
-              </a:rPr>
-              <a:t> (over all parameters), computes a </a:t>
-            </a:r>
-            <a:r>
-              <a:rPr b="1" lang="en" sz="900">
-                <a:solidFill>
-                  <a:schemeClr val="dk1"/>
-                </a:solidFill>
-              </a:rPr>
-              <a:t>global norm</a:t>
-            </a:r>
-            <a:r>
-              <a:rPr lang="en" sz="900">
-                <a:solidFill>
-                  <a:schemeClr val="dk1"/>
-                </a:solidFill>
-              </a:rPr>
-              <a:t> (usually L2), and if that norm is bigger than your threshold </a:t>
-            </a:r>
-            <a:r>
-              <a:rPr lang="en" sz="900">
-                <a:solidFill>
-                  <a:srgbClr val="188038"/>
-                </a:solidFill>
-                <a:latin typeface="Roboto Mono"/>
-                <a:ea typeface="Roboto Mono"/>
-                <a:cs typeface="Roboto Mono"/>
-                <a:sym typeface="Roboto Mono"/>
-              </a:rPr>
-              <a:t>grad_clip</a:t>
-            </a:r>
-            <a:r>
-              <a:rPr lang="en" sz="900">
-                <a:solidFill>
-                  <a:schemeClr val="dk1"/>
-                </a:solidFill>
-              </a:rPr>
-              <a:t>, it multiplies </a:t>
-            </a:r>
-            <a:r>
-              <a:rPr lang="en" sz="900">
-                <a:solidFill>
-                  <a:schemeClr val="dk1"/>
-                </a:solidFill>
-              </a:rPr>
-              <a:t>every gradient tensor</a:t>
-            </a:r>
-            <a:r>
-              <a:rPr lang="en" sz="900">
-                <a:solidFill>
-                  <a:schemeClr val="dk1"/>
-                </a:solidFill>
-              </a:rPr>
-              <a:t> by the same factor so the global norm becomes </a:t>
-            </a:r>
-            <a:r>
-              <a:rPr lang="en" sz="900">
-                <a:solidFill>
-                  <a:srgbClr val="188038"/>
-                </a:solidFill>
-                <a:latin typeface="Roboto Mono"/>
-                <a:ea typeface="Roboto Mono"/>
-                <a:cs typeface="Roboto Mono"/>
-                <a:sym typeface="Roboto Mono"/>
-              </a:rPr>
-              <a:t>grad_clip.</a:t>
-            </a:r>
-            <a:r>
-              <a:rPr lang="en" sz="900">
-                <a:solidFill>
-                  <a:schemeClr val="dk1"/>
-                </a:solidFill>
-              </a:rPr>
-              <a:t>It prevents large parameter updates due to gradient spikes. </a:t>
-            </a:r>
-            <a:r>
-              <a:rPr lang="en" sz="1200">
-                <a:solidFill>
-                  <a:schemeClr val="dk1"/>
-                </a:solidFill>
-              </a:rPr>
-              <a:t> </a:t>
-            </a:r>
-            <a:endParaRPr sz="1500"/>
-          </a:p>
-        </p:txBody>
-      </p:sp>
       <p:pic>
         <p:nvPicPr>
-          <p:cNvPr id="222" name="Google Shape;222;p30"/>
+          <p:cNvPr descr="{&quot;code&quot;:&quot;\\begin{gather*}\n{\\text{Let's}\\;\\text{calculate}\\;\\pdf{L}{x_{i}}}\\\\\n{\\pdf{L}{x_{i}}=\\sum_{j=1}^{D}\\pdf{L}{y_{j}}\\pdf{y_{j}}{x_{i}}}\\\\\n{\\text{As}\\;\\text{before,}\\;\\text{we}\\;\\text{denote}\\;\\pdf{L}{y_{j}}\\,\\text{by}\\;g_{j}}\\\\\n{\\pdf{y_{j}}{x_{i}}=\\lambda_{j}\\left[\\frac{r\\pdf{x_{j}}{x_{i}}-x_{j}\\pdf{r}{x_{i}}}{r^{2}}\\right]}\\\\\n{\\text{It}\\;\\text{is}\\;\\text{easy}\\;\\text{to}\\;\\text{verify}\\;\\text{that}\\;\\pdf{r}{x_{i}}=\\frac{x_{i}}{r}}\\\\\n{\\pdf{y_{j}}{x_{i}}=\\lambda_{j}\\left[\\frac{r\\pdf{x_{j}}{x_{i}}-x_{j}\\frac{x_{i}}{r}}{r^{2}}\\right]}\\\\\n{\\pdf{L}{x_{i}}=\\sum_{j=1,\\,j\\neq i}^{D}\\frac{-g_{j}\\lambda_{j}x_{j}x_{i}}{r^{3}}+\\lambda_{i}g_{i}\\left[\\frac{1}{r}-\\frac{x_{i}^{2}}{r^{3}}\\right]}\\\\\n{=\\frac{\\lambda_{i}g_{i}}{r}-\\sum_{j=1}^{D}\\frac{g_{j}\\lambda_{j}x_{j}x_{i}}{r^{3}}}\\\\\n{\\text{Denoting}\\;\\text{u=g}\\odot\\lambda}\\\\\n{\\pdf{L}{x}=\\frac{u}{r}-\\frac{x}{r^{3}}u^{T}x,\\,\\text{here}\\;x\\,\\text{is}\\;\\text{the}\\;\\text{entire}\\;\\text{feature}\\;\\text{vector}}\t\n\\end{gather*}&quot;,&quot;backgroundColorModified&quot;:false,&quot;id&quot;:&quot;13&quot;,&quot;backgroundColor&quot;:&quot;#FFFFFF&quot;,&quot;type&quot;:&quot;gather*&quot;,&quot;aid&quot;:null,&quot;font&quot;:{&quot;family&quot;:&quot;Arial&quot;,&quot;color&quot;:&quot;#000000&quot;,&quot;size&quot;:11},&quot;ts&quot;:1772898003840,&quot;cs&quot;:&quot;zn+9u9YdzdsMgNRfplaAwg==&quot;,&quot;size&quot;:{&quot;width&quot;:401.1023162729659,&quot;height&quot;:501.7216960629921}}" id="218" name="Google Shape;218;p30"/>
           <p:cNvPicPr preferRelativeResize="0"/>
           <p:nvPr/>
         </p:nvPicPr>
@@ -10375,8 +10115,8 @@
         </p:blipFill>
         <p:spPr>
           <a:xfrm>
-            <a:off x="2651272" y="1830947"/>
-            <a:ext cx="2833025" cy="1872700"/>
+            <a:off x="3670626" y="161575"/>
+            <a:ext cx="3820500" cy="4778899"/>
           </a:xfrm>
           <a:prstGeom prst="rect">
             <a:avLst/>
@@ -10387,186 +10127,51 @@
           </a:ln>
         </p:spPr>
       </p:pic>
-      <p:cxnSp>
-        <p:nvCxnSpPr>
-          <p:cNvPr id="223" name="Google Shape;223;p30"/>
-          <p:cNvCxnSpPr>
-            <a:stCxn id="216" idx="1"/>
-          </p:cNvCxnSpPr>
-          <p:nvPr/>
-        </p:nvCxnSpPr>
-        <p:spPr>
-          <a:xfrm flipH="1">
-            <a:off x="4903500" y="1456425"/>
-            <a:ext cx="551400" cy="413400"/>
-          </a:xfrm>
-          <a:prstGeom prst="straightConnector1">
-            <a:avLst/>
-          </a:prstGeom>
-          <a:noFill/>
-          <a:ln cap="flat" cmpd="sng" w="9525">
-            <a:solidFill>
-              <a:schemeClr val="dk2"/>
-            </a:solidFill>
-            <a:prstDash val="solid"/>
-            <a:round/>
-            <a:headEnd len="med" w="med" type="none"/>
-            <a:tailEnd len="med" w="med" type="triangle"/>
-          </a:ln>
-        </p:spPr>
-      </p:cxnSp>
-      <p:cxnSp>
-        <p:nvCxnSpPr>
-          <p:cNvPr id="224" name="Google Shape;224;p30"/>
-          <p:cNvCxnSpPr/>
-          <p:nvPr/>
-        </p:nvCxnSpPr>
-        <p:spPr>
-          <a:xfrm flipH="1">
-            <a:off x="4492350" y="2273675"/>
-            <a:ext cx="1093800" cy="252000"/>
-          </a:xfrm>
-          <a:prstGeom prst="straightConnector1">
-            <a:avLst/>
-          </a:prstGeom>
-          <a:noFill/>
-          <a:ln cap="flat" cmpd="sng" w="9525">
-            <a:solidFill>
-              <a:schemeClr val="dk2"/>
-            </a:solidFill>
-            <a:prstDash val="solid"/>
-            <a:round/>
-            <a:headEnd len="med" w="med" type="none"/>
-            <a:tailEnd len="med" w="med" type="triangle"/>
-          </a:ln>
-        </p:spPr>
-      </p:cxnSp>
-      <p:cxnSp>
-        <p:nvCxnSpPr>
-          <p:cNvPr id="225" name="Google Shape;225;p30"/>
-          <p:cNvCxnSpPr/>
-          <p:nvPr/>
-        </p:nvCxnSpPr>
-        <p:spPr>
-          <a:xfrm>
-            <a:off x="2308025" y="1830950"/>
-            <a:ext cx="739200" cy="953100"/>
-          </a:xfrm>
-          <a:prstGeom prst="straightConnector1">
-            <a:avLst/>
-          </a:prstGeom>
-          <a:noFill/>
-          <a:ln cap="flat" cmpd="sng" w="9525">
-            <a:solidFill>
-              <a:schemeClr val="dk2"/>
-            </a:solidFill>
-            <a:prstDash val="solid"/>
-            <a:round/>
-            <a:headEnd len="med" w="med" type="none"/>
-            <a:tailEnd len="med" w="med" type="triangle"/>
-          </a:ln>
-        </p:spPr>
-      </p:cxnSp>
-      <p:cxnSp>
-        <p:nvCxnSpPr>
-          <p:cNvPr id="226" name="Google Shape;226;p30"/>
-          <p:cNvCxnSpPr/>
-          <p:nvPr/>
-        </p:nvCxnSpPr>
-        <p:spPr>
-          <a:xfrm flipH="1" rot="10800000">
-            <a:off x="2276250" y="3024225"/>
-            <a:ext cx="401700" cy="23100"/>
-          </a:xfrm>
-          <a:prstGeom prst="straightConnector1">
-            <a:avLst/>
-          </a:prstGeom>
-          <a:noFill/>
-          <a:ln cap="flat" cmpd="sng" w="9525">
-            <a:solidFill>
-              <a:schemeClr val="dk2"/>
-            </a:solidFill>
-            <a:prstDash val="solid"/>
-            <a:round/>
-            <a:headEnd len="med" w="med" type="none"/>
-            <a:tailEnd len="med" w="med" type="triangle"/>
-          </a:ln>
-        </p:spPr>
-      </p:cxnSp>
-      <p:cxnSp>
-        <p:nvCxnSpPr>
-          <p:cNvPr id="227" name="Google Shape;227;p30"/>
-          <p:cNvCxnSpPr/>
-          <p:nvPr/>
-        </p:nvCxnSpPr>
-        <p:spPr>
-          <a:xfrm flipH="1" rot="10800000">
-            <a:off x="1906325" y="3472125"/>
-            <a:ext cx="780900" cy="496200"/>
-          </a:xfrm>
-          <a:prstGeom prst="straightConnector1">
-            <a:avLst/>
-          </a:prstGeom>
-          <a:noFill/>
-          <a:ln cap="flat" cmpd="sng" w="9525">
-            <a:solidFill>
-              <a:schemeClr val="dk2"/>
-            </a:solidFill>
-            <a:prstDash val="solid"/>
-            <a:round/>
-            <a:headEnd len="med" w="med" type="none"/>
-            <a:tailEnd len="med" w="med" type="triangle"/>
-          </a:ln>
-        </p:spPr>
-      </p:cxnSp>
-      <p:cxnSp>
-        <p:nvCxnSpPr>
-          <p:cNvPr id="228" name="Google Shape;228;p30"/>
-          <p:cNvCxnSpPr/>
-          <p:nvPr/>
-        </p:nvCxnSpPr>
-        <p:spPr>
-          <a:xfrm rot="10800000">
-            <a:off x="3287550" y="3675250"/>
-            <a:ext cx="451800" cy="505500"/>
-          </a:xfrm>
-          <a:prstGeom prst="straightConnector1">
-            <a:avLst/>
-          </a:prstGeom>
-          <a:noFill/>
-          <a:ln cap="flat" cmpd="sng" w="9525">
-            <a:solidFill>
-              <a:schemeClr val="dk2"/>
-            </a:solidFill>
-            <a:prstDash val="solid"/>
-            <a:round/>
-            <a:headEnd len="med" w="med" type="none"/>
-            <a:tailEnd len="med" w="med" type="triangle"/>
-          </a:ln>
-        </p:spPr>
-      </p:cxnSp>
-      <p:sp>
-        <p:nvSpPr>
-          <p:cNvPr id="229" name="Google Shape;229;p30"/>
+    </p:spTree>
+  </p:cSld>
+  <p:clrMapOvr>
+    <a:masterClrMapping/>
+  </p:clrMapOvr>
+</p:sld>
+</file>
+
+<file path=ppt/slides/slide19.xml><?xml version="1.0" encoding="utf-8"?>
+<p:sld xmlns:a="http://schemas.openxmlformats.org/drawingml/2006/main" xmlns:r="http://schemas.openxmlformats.org/officeDocument/2006/relationships" xmlns:mc="http://schemas.openxmlformats.org/markup-compatibility/2006" xmlns:mv="urn:schemas-microsoft-com:mac:vml" xmlns:p="http://schemas.openxmlformats.org/presentationml/2006/main" xmlns:c="http://schemas.openxmlformats.org/drawingml/2006/chart" xmlns:dgm="http://schemas.openxmlformats.org/drawingml/2006/diagram" xmlns:o="urn:schemas-microsoft-com:office:office" xmlns:v="urn:schemas-microsoft-com:vml" xmlns:pvml="urn:schemas-microsoft-com:office:powerpoint" xmlns:com="http://schemas.openxmlformats.org/drawingml/2006/compatibility" xmlns:p14="http://schemas.microsoft.com/office/powerpoint/2010/main" xmlns:p15="http://schemas.microsoft.com/office/powerpoint/2012/main" xmlns:ahyp="http://schemas.microsoft.com/office/drawing/2018/hyperlinkcolor">
+  <p:cSld>
+    <p:spTree>
+      <p:nvGrpSpPr>
+        <p:cNvPr id="222" name="Shape 222"/>
+        <p:cNvGrpSpPr/>
+        <p:nvPr/>
+      </p:nvGrpSpPr>
+      <p:grpSpPr>
+        <a:xfrm>
+          <a:off x="0" y="0"/>
+          <a:ext cx="0" cy="0"/>
+          <a:chOff x="0" y="0"/>
+          <a:chExt cx="0" cy="0"/>
+        </a:xfrm>
+      </p:grpSpPr>
+      <p:sp>
+        <p:nvSpPr>
+          <p:cNvPr id="223" name="Google Shape;223;p31"/>
           <p:cNvSpPr txBox="1"/>
-          <p:nvPr/>
-        </p:nvSpPr>
-        <p:spPr>
-          <a:xfrm>
-            <a:off x="5937600" y="3601250"/>
-            <a:ext cx="3000000" cy="1262100"/>
+          <p:nvPr>
+            <p:ph type="title"/>
+          </p:nvPr>
+        </p:nvSpPr>
+        <p:spPr>
+          <a:xfrm>
+            <a:off x="311700" y="445025"/>
+            <a:ext cx="8520600" cy="572700"/>
           </a:xfrm>
           <a:prstGeom prst="rect">
             <a:avLst/>
           </a:prstGeom>
-          <a:noFill/>
-          <a:ln>
-            <a:noFill/>
-          </a:ln>
         </p:spPr>
         <p:txBody>
           <a:bodyPr anchorCtr="0" anchor="t" bIns="91425" lIns="91425" spcFirstLastPara="1" rIns="91425" wrap="square" tIns="91425">
-            <a:spAutoFit/>
+            <a:normAutofit fontScale="90000"/>
           </a:bodyPr>
           <a:lstStyle/>
           <a:p>
@@ -10580,155 +10185,118 @@
               <a:buNone/>
             </a:pPr>
             <a:r>
-              <a:rPr b="1" lang="en" sz="1000"/>
-              <a:t>Default precision:</a:t>
-            </a:r>
-            <a:endParaRPr b="1" sz="1000"/>
-          </a:p>
-          <a:p>
-            <a:pPr indent="0" lvl="0" marL="0" rtl="0" algn="l">
-              <a:spcBef>
-                <a:spcPts val="0"/>
-              </a:spcBef>
-              <a:spcAft>
-                <a:spcPts val="0"/>
-              </a:spcAft>
-              <a:buNone/>
-            </a:pPr>
-            <a:r>
-              <a:rPr lang="en" sz="1000"/>
-              <a:t>Total execution time = 2.549 sec</a:t>
-            </a:r>
-            <a:endParaRPr sz="1000"/>
-          </a:p>
-          <a:p>
-            <a:pPr indent="0" lvl="0" marL="0" rtl="0" algn="l">
-              <a:spcBef>
-                <a:spcPts val="0"/>
-              </a:spcBef>
-              <a:spcAft>
-                <a:spcPts val="0"/>
-              </a:spcAft>
-              <a:buNone/>
-            </a:pPr>
-            <a:r>
-              <a:rPr lang="en" sz="1000"/>
-              <a:t>Max memory used by tensors = 2.78 GB</a:t>
-            </a:r>
-            <a:endParaRPr sz="1000"/>
-          </a:p>
-          <a:p>
-            <a:pPr indent="0" lvl="0" marL="0" rtl="0" algn="l">
-              <a:spcBef>
-                <a:spcPts val="0"/>
-              </a:spcBef>
-              <a:spcAft>
-                <a:spcPts val="0"/>
-              </a:spcAft>
-              <a:buNone/>
-            </a:pPr>
-            <a:r>
-              <a:t/>
-            </a:r>
-            <a:endParaRPr sz="1000"/>
-          </a:p>
-          <a:p>
-            <a:pPr indent="0" lvl="0" marL="0" rtl="0" algn="l">
-              <a:spcBef>
-                <a:spcPts val="0"/>
-              </a:spcBef>
-              <a:spcAft>
-                <a:spcPts val="0"/>
-              </a:spcAft>
-              <a:buNone/>
-            </a:pPr>
-            <a:r>
-              <a:rPr b="1" lang="en" sz="1000"/>
-              <a:t>Mixed precision:</a:t>
-            </a:r>
-            <a:endParaRPr b="1" sz="1000"/>
-          </a:p>
-          <a:p>
-            <a:pPr indent="0" lvl="0" marL="0" rtl="0" algn="l">
-              <a:spcBef>
-                <a:spcPts val="0"/>
-              </a:spcBef>
-              <a:spcAft>
-                <a:spcPts val="0"/>
-              </a:spcAft>
-              <a:buNone/>
-            </a:pPr>
-            <a:r>
-              <a:rPr lang="en" sz="1000"/>
-              <a:t>Total execution time = 1.354 sec</a:t>
-            </a:r>
-            <a:endParaRPr sz="1000"/>
-          </a:p>
-          <a:p>
-            <a:pPr indent="0" lvl="0" marL="0" rtl="0" algn="l">
-              <a:spcBef>
-                <a:spcPts val="0"/>
-              </a:spcBef>
-              <a:spcAft>
-                <a:spcPts val="0"/>
-              </a:spcAft>
-              <a:buNone/>
-            </a:pPr>
-            <a:r>
-              <a:rPr lang="en" sz="1000"/>
-              <a:t>Max memory used by tensors = 2.76 GB</a:t>
-            </a:r>
-            <a:endParaRPr sz="1000"/>
+              <a:rPr lang="en"/>
+              <a:t>Common tricks..</a:t>
+            </a:r>
+            <a:endParaRPr/>
           </a:p>
         </p:txBody>
       </p:sp>
       <p:sp>
         <p:nvSpPr>
-          <p:cNvPr id="230" name="Google Shape;230;p30"/>
+          <p:cNvPr id="224" name="Google Shape;224;p31"/>
           <p:cNvSpPr txBox="1"/>
-          <p:nvPr/>
-        </p:nvSpPr>
-        <p:spPr>
-          <a:xfrm>
-            <a:off x="56425" y="4723350"/>
-            <a:ext cx="3000000" cy="338700"/>
+          <p:nvPr>
+            <p:ph idx="1" type="body"/>
+          </p:nvPr>
+        </p:nvSpPr>
+        <p:spPr>
+          <a:xfrm>
+            <a:off x="311700" y="1152475"/>
+            <a:ext cx="8520600" cy="3416400"/>
           </a:xfrm>
           <a:prstGeom prst="rect">
             <a:avLst/>
           </a:prstGeom>
-          <a:noFill/>
-          <a:ln>
-            <a:noFill/>
-          </a:ln>
         </p:spPr>
         <p:txBody>
           <a:bodyPr anchorCtr="0" anchor="t" bIns="91425" lIns="91425" spcFirstLastPara="1" rIns="91425" wrap="square" tIns="91425">
-            <a:spAutoFit/>
+            <a:normAutofit/>
           </a:bodyPr>
           <a:lstStyle/>
           <a:p>
-            <a:pPr indent="0" lvl="0" marL="0" rtl="0" algn="l">
-              <a:spcBef>
-                <a:spcPts val="0"/>
-              </a:spcBef>
-              <a:spcAft>
-                <a:spcPts val="0"/>
-              </a:spcAft>
-              <a:buNone/>
+            <a:pPr indent="-342900" lvl="0" marL="457200" rtl="0" algn="l">
+              <a:spcBef>
+                <a:spcPts val="0"/>
+              </a:spcBef>
+              <a:spcAft>
+                <a:spcPts val="0"/>
+              </a:spcAft>
+              <a:buSzPts val="1800"/>
+              <a:buChar char="-"/>
             </a:pPr>
             <a:r>
-              <a:rPr lang="en" sz="1000">
-                <a:solidFill>
-                  <a:schemeClr val="dk1"/>
-                </a:solidFill>
-              </a:rPr>
-              <a:t>full_vs_mixed_precision_timing.py</a:t>
-            </a:r>
-            <a:endParaRPr sz="1000">
-              <a:solidFill>
-                <a:srgbClr val="BCBEC4"/>
-              </a:solidFill>
-            </a:endParaRPr>
+              <a:rPr lang="en"/>
+              <a:t>Data augmentation</a:t>
+            </a:r>
+            <a:endParaRPr/>
+          </a:p>
+          <a:p>
+            <a:pPr indent="-342900" lvl="0" marL="457200" rtl="0" algn="l">
+              <a:spcBef>
+                <a:spcPts val="0"/>
+              </a:spcBef>
+              <a:spcAft>
+                <a:spcPts val="0"/>
+              </a:spcAft>
+              <a:buSzPts val="1800"/>
+              <a:buChar char="-"/>
+            </a:pPr>
+            <a:r>
+              <a:rPr lang="en"/>
+              <a:t>Setting up a convolutional network with downsampling points (using striding) accompanied by increase in channels</a:t>
+            </a:r>
+            <a:endParaRPr/>
+          </a:p>
+          <a:p>
+            <a:pPr indent="-342900" lvl="0" marL="457200" rtl="0" algn="l">
+              <a:spcBef>
+                <a:spcPts val="0"/>
+              </a:spcBef>
+              <a:spcAft>
+                <a:spcPts val="0"/>
+              </a:spcAft>
+              <a:buSzPts val="1800"/>
+              <a:buChar char="-"/>
+            </a:pPr>
+            <a:r>
+              <a:rPr lang="en"/>
+              <a:t>In the </a:t>
+            </a:r>
+            <a:r>
+              <a:rPr lang="en"/>
+              <a:t>batch</a:t>
+            </a:r>
+            <a:r>
+              <a:rPr lang="en"/>
+              <a:t> normalization + residual connection implementation, using the concept of blocks. Each block has several convolutional layers. First convolutional layer halves the spatial dimension and doubles the number of channels.</a:t>
+            </a:r>
+            <a:endParaRPr/>
+          </a:p>
+          <a:p>
+            <a:pPr indent="-342900" lvl="0" marL="457200" rtl="0" algn="l">
+              <a:spcBef>
+                <a:spcPts val="0"/>
+              </a:spcBef>
+              <a:spcAft>
+                <a:spcPts val="0"/>
+              </a:spcAft>
+              <a:buSzPts val="1800"/>
+              <a:buChar char="-"/>
+            </a:pPr>
+            <a:r>
+              <a:rPr lang="en"/>
+              <a:t>In the </a:t>
+            </a:r>
+            <a:r>
+              <a:rPr lang="en"/>
+              <a:t>residual</a:t>
+            </a:r>
+            <a:r>
+              <a:rPr lang="en"/>
+              <a:t> connection, add a 1d conv if spatial dimension change</a:t>
+            </a:r>
+            <a:endParaRPr/>
           </a:p>
         </p:txBody>
       </p:sp>
@@ -11003,6 +10571,904 @@
               <a:t>Forward and backward pass in low precision</a:t>
             </a:r>
             <a:endParaRPr sz="1300"/>
+          </a:p>
+        </p:txBody>
+      </p:sp>
+    </p:spTree>
+  </p:cSld>
+  <p:clrMapOvr>
+    <a:masterClrMapping/>
+  </p:clrMapOvr>
+</p:sld>
+</file>
+
+<file path=ppt/slides/slide20.xml><?xml version="1.0" encoding="utf-8"?>
+<p:sld xmlns:a="http://schemas.openxmlformats.org/drawingml/2006/main" xmlns:r="http://schemas.openxmlformats.org/officeDocument/2006/relationships" xmlns:mc="http://schemas.openxmlformats.org/markup-compatibility/2006" xmlns:mv="urn:schemas-microsoft-com:mac:vml" xmlns:p="http://schemas.openxmlformats.org/presentationml/2006/main" xmlns:c="http://schemas.openxmlformats.org/drawingml/2006/chart" xmlns:dgm="http://schemas.openxmlformats.org/drawingml/2006/diagram" xmlns:o="urn:schemas-microsoft-com:office:office" xmlns:v="urn:schemas-microsoft-com:vml" xmlns:pvml="urn:schemas-microsoft-com:office:powerpoint" xmlns:com="http://schemas.openxmlformats.org/drawingml/2006/compatibility" xmlns:p14="http://schemas.microsoft.com/office/powerpoint/2010/main" xmlns:p15="http://schemas.microsoft.com/office/powerpoint/2012/main" xmlns:ahyp="http://schemas.microsoft.com/office/drawing/2018/hyperlinkcolor">
+  <p:cSld>
+    <p:spTree>
+      <p:nvGrpSpPr>
+        <p:cNvPr id="228" name="Shape 228"/>
+        <p:cNvGrpSpPr/>
+        <p:nvPr/>
+      </p:nvGrpSpPr>
+      <p:grpSpPr>
+        <a:xfrm>
+          <a:off x="0" y="0"/>
+          <a:ext cx="0" cy="0"/>
+          <a:chOff x="0" y="0"/>
+          <a:chExt cx="0" cy="0"/>
+        </a:xfrm>
+      </p:grpSpPr>
+      <p:sp>
+        <p:nvSpPr>
+          <p:cNvPr id="229" name="Google Shape;229;p32"/>
+          <p:cNvSpPr txBox="1"/>
+          <p:nvPr>
+            <p:ph type="title"/>
+          </p:nvPr>
+        </p:nvSpPr>
+        <p:spPr>
+          <a:xfrm>
+            <a:off x="311700" y="445025"/>
+            <a:ext cx="8520600" cy="572700"/>
+          </a:xfrm>
+          <a:prstGeom prst="rect">
+            <a:avLst/>
+          </a:prstGeom>
+        </p:spPr>
+        <p:txBody>
+          <a:bodyPr anchorCtr="0" anchor="t" bIns="91425" lIns="91425" spcFirstLastPara="1" rIns="91425" wrap="square" tIns="91425">
+            <a:normAutofit fontScale="90000"/>
+          </a:bodyPr>
+          <a:lstStyle/>
+          <a:p>
+            <a:pPr indent="0" lvl="0" marL="0" rtl="0" algn="l">
+              <a:spcBef>
+                <a:spcPts val="0"/>
+              </a:spcBef>
+              <a:spcAft>
+                <a:spcPts val="0"/>
+              </a:spcAft>
+              <a:buNone/>
+            </a:pPr>
+            <a:r>
+              <a:rPr lang="en"/>
+              <a:t>Using lower precision data types in the </a:t>
+            </a:r>
+            <a:r>
+              <a:rPr lang="en"/>
+              <a:t>training</a:t>
+            </a:r>
+            <a:r>
+              <a:rPr lang="en"/>
+              <a:t> loop</a:t>
+            </a:r>
+            <a:endParaRPr/>
+          </a:p>
+        </p:txBody>
+      </p:sp>
+      <p:sp>
+        <p:nvSpPr>
+          <p:cNvPr id="230" name="Google Shape;230;p32"/>
+          <p:cNvSpPr txBox="1"/>
+          <p:nvPr/>
+        </p:nvSpPr>
+        <p:spPr>
+          <a:xfrm>
+            <a:off x="5454900" y="1156275"/>
+            <a:ext cx="3585600" cy="600300"/>
+          </a:xfrm>
+          <a:prstGeom prst="rect">
+            <a:avLst/>
+          </a:prstGeom>
+          <a:noFill/>
+          <a:ln>
+            <a:noFill/>
+          </a:ln>
+        </p:spPr>
+        <p:txBody>
+          <a:bodyPr anchorCtr="0" anchor="t" bIns="91425" lIns="91425" spcFirstLastPara="1" rIns="91425" wrap="square" tIns="91425">
+            <a:spAutoFit/>
+          </a:bodyPr>
+          <a:lstStyle/>
+          <a:p>
+            <a:pPr indent="0" lvl="0" marL="0" rtl="0" algn="l">
+              <a:spcBef>
+                <a:spcPts val="0"/>
+              </a:spcBef>
+              <a:spcAft>
+                <a:spcPts val="0"/>
+              </a:spcAft>
+              <a:buNone/>
+            </a:pPr>
+            <a:r>
+              <a:rPr lang="en" sz="900">
+                <a:solidFill>
+                  <a:schemeClr val="dk1"/>
+                </a:solidFill>
+              </a:rPr>
+              <a:t>A</a:t>
+            </a:r>
+            <a:r>
+              <a:rPr lang="en" sz="900">
+                <a:solidFill>
+                  <a:schemeClr val="dk1"/>
+                </a:solidFill>
+              </a:rPr>
+              <a:t>ffects </a:t>
+            </a:r>
+            <a:r>
+              <a:rPr b="1" lang="en" sz="900">
+                <a:solidFill>
+                  <a:schemeClr val="dk1"/>
+                </a:solidFill>
+              </a:rPr>
+              <a:t>ops executed inside the context</a:t>
+            </a:r>
+            <a:r>
+              <a:rPr lang="en" sz="900">
+                <a:solidFill>
+                  <a:schemeClr val="dk1"/>
+                </a:solidFill>
+              </a:rPr>
+              <a:t> by choosing a “fast” dtype for each op (fp16/bf16 for many GEMMs/convs, fp32 for numerically sensitive ops like some reductions/softmax parts, etc.)</a:t>
+            </a:r>
+            <a:endParaRPr sz="1200"/>
+          </a:p>
+        </p:txBody>
+      </p:sp>
+      <p:sp>
+        <p:nvSpPr>
+          <p:cNvPr id="231" name="Google Shape;231;p32"/>
+          <p:cNvSpPr txBox="1"/>
+          <p:nvPr/>
+        </p:nvSpPr>
+        <p:spPr>
+          <a:xfrm>
+            <a:off x="5557800" y="1978100"/>
+            <a:ext cx="3379800" cy="1262100"/>
+          </a:xfrm>
+          <a:prstGeom prst="rect">
+            <a:avLst/>
+          </a:prstGeom>
+          <a:noFill/>
+          <a:ln>
+            <a:noFill/>
+          </a:ln>
+        </p:spPr>
+        <p:txBody>
+          <a:bodyPr anchorCtr="0" anchor="t" bIns="91425" lIns="91425" spcFirstLastPara="1" rIns="91425" wrap="square" tIns="91425">
+            <a:spAutoFit/>
+          </a:bodyPr>
+          <a:lstStyle/>
+          <a:p>
+            <a:pPr indent="0" lvl="0" marL="0" rtl="0" algn="l">
+              <a:spcBef>
+                <a:spcPts val="0"/>
+              </a:spcBef>
+              <a:spcAft>
+                <a:spcPts val="0"/>
+              </a:spcAft>
+              <a:buNone/>
+            </a:pPr>
+            <a:r>
+              <a:rPr lang="en" sz="1000">
+                <a:solidFill>
+                  <a:schemeClr val="dk1"/>
+                </a:solidFill>
+              </a:rPr>
+              <a:t>If we computed gradients also in a lower dtype (eg., fp16), small gradients might underflow to 0. So, we scale up the loss and then calculate the gradients. This way gradient flow is preserved. Also, gradients often sum many contributions. In low precision, when you add a tiny number to a running total, the tiny increment can get rounded away. </a:t>
+            </a:r>
+            <a:endParaRPr sz="1300"/>
+          </a:p>
+        </p:txBody>
+      </p:sp>
+      <p:sp>
+        <p:nvSpPr>
+          <p:cNvPr id="232" name="Google Shape;232;p32"/>
+          <p:cNvSpPr txBox="1"/>
+          <p:nvPr/>
+        </p:nvSpPr>
+        <p:spPr>
+          <a:xfrm>
+            <a:off x="97975" y="1177700"/>
+            <a:ext cx="2916900" cy="800400"/>
+          </a:xfrm>
+          <a:prstGeom prst="rect">
+            <a:avLst/>
+          </a:prstGeom>
+          <a:noFill/>
+          <a:ln>
+            <a:noFill/>
+          </a:ln>
+        </p:spPr>
+        <p:txBody>
+          <a:bodyPr anchorCtr="0" anchor="t" bIns="91425" lIns="91425" spcFirstLastPara="1" rIns="91425" wrap="square" tIns="91425">
+            <a:spAutoFit/>
+          </a:bodyPr>
+          <a:lstStyle/>
+          <a:p>
+            <a:pPr indent="0" lvl="0" marL="0" rtl="0" algn="l">
+              <a:spcBef>
+                <a:spcPts val="0"/>
+              </a:spcBef>
+              <a:spcAft>
+                <a:spcPts val="0"/>
+              </a:spcAft>
+              <a:buNone/>
+            </a:pPr>
+            <a:r>
+              <a:rPr lang="en" sz="1000">
+                <a:solidFill>
+                  <a:schemeClr val="dk1"/>
+                </a:solidFill>
+              </a:rPr>
+              <a:t>Once the gradients have been calculated, we scale them back to the original scale. Generally gradients are represented in full precision at this step, so underflow isn’t an issue </a:t>
+            </a:r>
+            <a:endParaRPr sz="1300"/>
+          </a:p>
+        </p:txBody>
+      </p:sp>
+      <p:sp>
+        <p:nvSpPr>
+          <p:cNvPr id="233" name="Google Shape;233;p32"/>
+          <p:cNvSpPr txBox="1"/>
+          <p:nvPr/>
+        </p:nvSpPr>
+        <p:spPr>
+          <a:xfrm>
+            <a:off x="235500" y="3945225"/>
+            <a:ext cx="3000000" cy="461700"/>
+          </a:xfrm>
+          <a:prstGeom prst="rect">
+            <a:avLst/>
+          </a:prstGeom>
+          <a:noFill/>
+          <a:ln>
+            <a:noFill/>
+          </a:ln>
+        </p:spPr>
+        <p:txBody>
+          <a:bodyPr anchorCtr="0" anchor="t" bIns="91425" lIns="91425" spcFirstLastPara="1" rIns="91425" wrap="square" tIns="91425">
+            <a:spAutoFit/>
+          </a:bodyPr>
+          <a:lstStyle/>
+          <a:p>
+            <a:pPr indent="0" lvl="0" marL="0" rtl="0" algn="l">
+              <a:spcBef>
+                <a:spcPts val="0"/>
+              </a:spcBef>
+              <a:spcAft>
+                <a:spcPts val="0"/>
+              </a:spcAft>
+              <a:buNone/>
+            </a:pPr>
+            <a:r>
+              <a:rPr lang="en" sz="900">
+                <a:solidFill>
+                  <a:schemeClr val="dk1"/>
+                </a:solidFill>
+              </a:rPr>
+              <a:t>checks if any grads are inf/nan. If yes, it </a:t>
+            </a:r>
+            <a:r>
+              <a:rPr b="1" lang="en" sz="900">
+                <a:solidFill>
+                  <a:schemeClr val="dk1"/>
+                </a:solidFill>
+              </a:rPr>
+              <a:t>skips</a:t>
+            </a:r>
+            <a:r>
+              <a:rPr lang="en" sz="900">
+                <a:solidFill>
+                  <a:schemeClr val="dk1"/>
+                </a:solidFill>
+              </a:rPr>
+              <a:t> </a:t>
+            </a:r>
+            <a:r>
+              <a:rPr lang="en" sz="900">
+                <a:solidFill>
+                  <a:schemeClr val="dk1"/>
+                </a:solidFill>
+              </a:rPr>
+              <a:t>optimizer.step().</a:t>
+            </a:r>
+            <a:endParaRPr sz="900">
+              <a:solidFill>
+                <a:schemeClr val="dk1"/>
+              </a:solidFill>
+            </a:endParaRPr>
+          </a:p>
+        </p:txBody>
+      </p:sp>
+      <p:sp>
+        <p:nvSpPr>
+          <p:cNvPr id="234" name="Google Shape;234;p32"/>
+          <p:cNvSpPr txBox="1"/>
+          <p:nvPr/>
+        </p:nvSpPr>
+        <p:spPr>
+          <a:xfrm>
+            <a:off x="3323700" y="4200575"/>
+            <a:ext cx="2496600" cy="492600"/>
+          </a:xfrm>
+          <a:prstGeom prst="rect">
+            <a:avLst/>
+          </a:prstGeom>
+          <a:noFill/>
+          <a:ln>
+            <a:noFill/>
+          </a:ln>
+        </p:spPr>
+        <p:txBody>
+          <a:bodyPr anchorCtr="0" anchor="t" bIns="91425" lIns="91425" spcFirstLastPara="1" rIns="91425" wrap="square" tIns="91425">
+            <a:spAutoFit/>
+          </a:bodyPr>
+          <a:lstStyle/>
+          <a:p>
+            <a:pPr indent="0" lvl="0" marL="0" rtl="0" algn="l">
+              <a:spcBef>
+                <a:spcPts val="0"/>
+              </a:spcBef>
+              <a:spcAft>
+                <a:spcPts val="0"/>
+              </a:spcAft>
+              <a:buNone/>
+            </a:pPr>
+            <a:r>
+              <a:rPr lang="en" sz="1000">
+                <a:solidFill>
+                  <a:schemeClr val="dk1"/>
+                </a:solidFill>
+              </a:rPr>
+              <a:t>A</a:t>
+            </a:r>
+            <a:r>
+              <a:rPr lang="en" sz="1000">
+                <a:solidFill>
+                  <a:schemeClr val="dk1"/>
+                </a:solidFill>
+              </a:rPr>
+              <a:t>djusts </a:t>
+            </a:r>
+            <a:r>
+              <a:rPr lang="en" sz="1000">
+                <a:solidFill>
+                  <a:srgbClr val="188038"/>
+                </a:solidFill>
+                <a:latin typeface="Roboto Mono"/>
+                <a:ea typeface="Roboto Mono"/>
+                <a:cs typeface="Roboto Mono"/>
+                <a:sym typeface="Roboto Mono"/>
+              </a:rPr>
+              <a:t>S</a:t>
+            </a:r>
+            <a:r>
+              <a:rPr lang="en" sz="1000">
+                <a:solidFill>
+                  <a:schemeClr val="dk1"/>
+                </a:solidFill>
+              </a:rPr>
+              <a:t> (down if overflow happened; up slowly if things are stable)</a:t>
+            </a:r>
+            <a:endParaRPr sz="1300"/>
+          </a:p>
+        </p:txBody>
+      </p:sp>
+      <p:sp>
+        <p:nvSpPr>
+          <p:cNvPr id="235" name="Google Shape;235;p32"/>
+          <p:cNvSpPr txBox="1"/>
+          <p:nvPr/>
+        </p:nvSpPr>
+        <p:spPr>
+          <a:xfrm>
+            <a:off x="0" y="2220850"/>
+            <a:ext cx="2396400" cy="1339200"/>
+          </a:xfrm>
+          <a:prstGeom prst="rect">
+            <a:avLst/>
+          </a:prstGeom>
+          <a:noFill/>
+          <a:ln>
+            <a:noFill/>
+          </a:ln>
+        </p:spPr>
+        <p:txBody>
+          <a:bodyPr anchorCtr="0" anchor="t" bIns="91425" lIns="91425" spcFirstLastPara="1" rIns="91425" wrap="square" tIns="91425">
+            <a:spAutoFit/>
+          </a:bodyPr>
+          <a:lstStyle/>
+          <a:p>
+            <a:pPr indent="0" lvl="0" marL="0" rtl="0" algn="l">
+              <a:spcBef>
+                <a:spcPts val="0"/>
+              </a:spcBef>
+              <a:spcAft>
+                <a:spcPts val="0"/>
+              </a:spcAft>
+              <a:buNone/>
+            </a:pPr>
+            <a:r>
+              <a:rPr lang="en" sz="900">
+                <a:solidFill>
+                  <a:schemeClr val="dk1"/>
+                </a:solidFill>
+              </a:rPr>
+              <a:t>It looks at </a:t>
+            </a:r>
+            <a:r>
+              <a:rPr b="1" lang="en" sz="900">
+                <a:solidFill>
+                  <a:schemeClr val="dk1"/>
+                </a:solidFill>
+              </a:rPr>
+              <a:t>all gradients together</a:t>
+            </a:r>
+            <a:r>
+              <a:rPr lang="en" sz="900">
+                <a:solidFill>
+                  <a:schemeClr val="dk1"/>
+                </a:solidFill>
+              </a:rPr>
+              <a:t> (over all parameters), computes a </a:t>
+            </a:r>
+            <a:r>
+              <a:rPr b="1" lang="en" sz="900">
+                <a:solidFill>
+                  <a:schemeClr val="dk1"/>
+                </a:solidFill>
+              </a:rPr>
+              <a:t>global norm</a:t>
+            </a:r>
+            <a:r>
+              <a:rPr lang="en" sz="900">
+                <a:solidFill>
+                  <a:schemeClr val="dk1"/>
+                </a:solidFill>
+              </a:rPr>
+              <a:t> (usually L2), and if that norm is bigger than your threshold </a:t>
+            </a:r>
+            <a:r>
+              <a:rPr lang="en" sz="900">
+                <a:solidFill>
+                  <a:srgbClr val="188038"/>
+                </a:solidFill>
+                <a:latin typeface="Roboto Mono"/>
+                <a:ea typeface="Roboto Mono"/>
+                <a:cs typeface="Roboto Mono"/>
+                <a:sym typeface="Roboto Mono"/>
+              </a:rPr>
+              <a:t>grad_clip</a:t>
+            </a:r>
+            <a:r>
+              <a:rPr lang="en" sz="900">
+                <a:solidFill>
+                  <a:schemeClr val="dk1"/>
+                </a:solidFill>
+              </a:rPr>
+              <a:t>, it multiplies </a:t>
+            </a:r>
+            <a:r>
+              <a:rPr lang="en" sz="900">
+                <a:solidFill>
+                  <a:schemeClr val="dk1"/>
+                </a:solidFill>
+              </a:rPr>
+              <a:t>every gradient tensor</a:t>
+            </a:r>
+            <a:r>
+              <a:rPr lang="en" sz="900">
+                <a:solidFill>
+                  <a:schemeClr val="dk1"/>
+                </a:solidFill>
+              </a:rPr>
+              <a:t> by the same factor so the global norm becomes </a:t>
+            </a:r>
+            <a:r>
+              <a:rPr lang="en" sz="900">
+                <a:solidFill>
+                  <a:srgbClr val="188038"/>
+                </a:solidFill>
+                <a:latin typeface="Roboto Mono"/>
+                <a:ea typeface="Roboto Mono"/>
+                <a:cs typeface="Roboto Mono"/>
+                <a:sym typeface="Roboto Mono"/>
+              </a:rPr>
+              <a:t>grad_clip.</a:t>
+            </a:r>
+            <a:r>
+              <a:rPr lang="en" sz="900">
+                <a:solidFill>
+                  <a:schemeClr val="dk1"/>
+                </a:solidFill>
+              </a:rPr>
+              <a:t>It prevents large parameter updates due to gradient spikes. </a:t>
+            </a:r>
+            <a:r>
+              <a:rPr lang="en" sz="1200">
+                <a:solidFill>
+                  <a:schemeClr val="dk1"/>
+                </a:solidFill>
+              </a:rPr>
+              <a:t> </a:t>
+            </a:r>
+            <a:endParaRPr sz="1500"/>
+          </a:p>
+        </p:txBody>
+      </p:sp>
+      <p:pic>
+        <p:nvPicPr>
+          <p:cNvPr id="236" name="Google Shape;236;p32"/>
+          <p:cNvPicPr preferRelativeResize="0"/>
+          <p:nvPr/>
+        </p:nvPicPr>
+        <p:blipFill>
+          <a:blip r:embed="rId3">
+            <a:alphaModFix/>
+          </a:blip>
+          <a:stretch>
+            <a:fillRect/>
+          </a:stretch>
+        </p:blipFill>
+        <p:spPr>
+          <a:xfrm>
+            <a:off x="2651272" y="1830947"/>
+            <a:ext cx="2833025" cy="1872700"/>
+          </a:xfrm>
+          <a:prstGeom prst="rect">
+            <a:avLst/>
+          </a:prstGeom>
+          <a:noFill/>
+          <a:ln>
+            <a:noFill/>
+          </a:ln>
+        </p:spPr>
+      </p:pic>
+      <p:cxnSp>
+        <p:nvCxnSpPr>
+          <p:cNvPr id="237" name="Google Shape;237;p32"/>
+          <p:cNvCxnSpPr>
+            <a:stCxn id="230" idx="1"/>
+          </p:cNvCxnSpPr>
+          <p:nvPr/>
+        </p:nvCxnSpPr>
+        <p:spPr>
+          <a:xfrm flipH="1">
+            <a:off x="4903500" y="1456425"/>
+            <a:ext cx="551400" cy="413400"/>
+          </a:xfrm>
+          <a:prstGeom prst="straightConnector1">
+            <a:avLst/>
+          </a:prstGeom>
+          <a:noFill/>
+          <a:ln cap="flat" cmpd="sng" w="9525">
+            <a:solidFill>
+              <a:schemeClr val="dk2"/>
+            </a:solidFill>
+            <a:prstDash val="solid"/>
+            <a:round/>
+            <a:headEnd len="med" w="med" type="none"/>
+            <a:tailEnd len="med" w="med" type="triangle"/>
+          </a:ln>
+        </p:spPr>
+      </p:cxnSp>
+      <p:cxnSp>
+        <p:nvCxnSpPr>
+          <p:cNvPr id="238" name="Google Shape;238;p32"/>
+          <p:cNvCxnSpPr/>
+          <p:nvPr/>
+        </p:nvCxnSpPr>
+        <p:spPr>
+          <a:xfrm flipH="1">
+            <a:off x="4492350" y="2273675"/>
+            <a:ext cx="1093800" cy="252000"/>
+          </a:xfrm>
+          <a:prstGeom prst="straightConnector1">
+            <a:avLst/>
+          </a:prstGeom>
+          <a:noFill/>
+          <a:ln cap="flat" cmpd="sng" w="9525">
+            <a:solidFill>
+              <a:schemeClr val="dk2"/>
+            </a:solidFill>
+            <a:prstDash val="solid"/>
+            <a:round/>
+            <a:headEnd len="med" w="med" type="none"/>
+            <a:tailEnd len="med" w="med" type="triangle"/>
+          </a:ln>
+        </p:spPr>
+      </p:cxnSp>
+      <p:cxnSp>
+        <p:nvCxnSpPr>
+          <p:cNvPr id="239" name="Google Shape;239;p32"/>
+          <p:cNvCxnSpPr/>
+          <p:nvPr/>
+        </p:nvCxnSpPr>
+        <p:spPr>
+          <a:xfrm>
+            <a:off x="2308025" y="1830950"/>
+            <a:ext cx="739200" cy="953100"/>
+          </a:xfrm>
+          <a:prstGeom prst="straightConnector1">
+            <a:avLst/>
+          </a:prstGeom>
+          <a:noFill/>
+          <a:ln cap="flat" cmpd="sng" w="9525">
+            <a:solidFill>
+              <a:schemeClr val="dk2"/>
+            </a:solidFill>
+            <a:prstDash val="solid"/>
+            <a:round/>
+            <a:headEnd len="med" w="med" type="none"/>
+            <a:tailEnd len="med" w="med" type="triangle"/>
+          </a:ln>
+        </p:spPr>
+      </p:cxnSp>
+      <p:cxnSp>
+        <p:nvCxnSpPr>
+          <p:cNvPr id="240" name="Google Shape;240;p32"/>
+          <p:cNvCxnSpPr/>
+          <p:nvPr/>
+        </p:nvCxnSpPr>
+        <p:spPr>
+          <a:xfrm flipH="1" rot="10800000">
+            <a:off x="2276250" y="3024225"/>
+            <a:ext cx="401700" cy="23100"/>
+          </a:xfrm>
+          <a:prstGeom prst="straightConnector1">
+            <a:avLst/>
+          </a:prstGeom>
+          <a:noFill/>
+          <a:ln cap="flat" cmpd="sng" w="9525">
+            <a:solidFill>
+              <a:schemeClr val="dk2"/>
+            </a:solidFill>
+            <a:prstDash val="solid"/>
+            <a:round/>
+            <a:headEnd len="med" w="med" type="none"/>
+            <a:tailEnd len="med" w="med" type="triangle"/>
+          </a:ln>
+        </p:spPr>
+      </p:cxnSp>
+      <p:cxnSp>
+        <p:nvCxnSpPr>
+          <p:cNvPr id="241" name="Google Shape;241;p32"/>
+          <p:cNvCxnSpPr/>
+          <p:nvPr/>
+        </p:nvCxnSpPr>
+        <p:spPr>
+          <a:xfrm flipH="1" rot="10800000">
+            <a:off x="1906325" y="3472125"/>
+            <a:ext cx="780900" cy="496200"/>
+          </a:xfrm>
+          <a:prstGeom prst="straightConnector1">
+            <a:avLst/>
+          </a:prstGeom>
+          <a:noFill/>
+          <a:ln cap="flat" cmpd="sng" w="9525">
+            <a:solidFill>
+              <a:schemeClr val="dk2"/>
+            </a:solidFill>
+            <a:prstDash val="solid"/>
+            <a:round/>
+            <a:headEnd len="med" w="med" type="none"/>
+            <a:tailEnd len="med" w="med" type="triangle"/>
+          </a:ln>
+        </p:spPr>
+      </p:cxnSp>
+      <p:cxnSp>
+        <p:nvCxnSpPr>
+          <p:cNvPr id="242" name="Google Shape;242;p32"/>
+          <p:cNvCxnSpPr/>
+          <p:nvPr/>
+        </p:nvCxnSpPr>
+        <p:spPr>
+          <a:xfrm rot="10800000">
+            <a:off x="3287550" y="3675250"/>
+            <a:ext cx="451800" cy="505500"/>
+          </a:xfrm>
+          <a:prstGeom prst="straightConnector1">
+            <a:avLst/>
+          </a:prstGeom>
+          <a:noFill/>
+          <a:ln cap="flat" cmpd="sng" w="9525">
+            <a:solidFill>
+              <a:schemeClr val="dk2"/>
+            </a:solidFill>
+            <a:prstDash val="solid"/>
+            <a:round/>
+            <a:headEnd len="med" w="med" type="none"/>
+            <a:tailEnd len="med" w="med" type="triangle"/>
+          </a:ln>
+        </p:spPr>
+      </p:cxnSp>
+      <p:sp>
+        <p:nvSpPr>
+          <p:cNvPr id="243" name="Google Shape;243;p32"/>
+          <p:cNvSpPr txBox="1"/>
+          <p:nvPr/>
+        </p:nvSpPr>
+        <p:spPr>
+          <a:xfrm>
+            <a:off x="5937600" y="3601250"/>
+            <a:ext cx="3000000" cy="1262100"/>
+          </a:xfrm>
+          <a:prstGeom prst="rect">
+            <a:avLst/>
+          </a:prstGeom>
+          <a:noFill/>
+          <a:ln>
+            <a:noFill/>
+          </a:ln>
+        </p:spPr>
+        <p:txBody>
+          <a:bodyPr anchorCtr="0" anchor="t" bIns="91425" lIns="91425" spcFirstLastPara="1" rIns="91425" wrap="square" tIns="91425">
+            <a:spAutoFit/>
+          </a:bodyPr>
+          <a:lstStyle/>
+          <a:p>
+            <a:pPr indent="0" lvl="0" marL="0" rtl="0" algn="l">
+              <a:spcBef>
+                <a:spcPts val="0"/>
+              </a:spcBef>
+              <a:spcAft>
+                <a:spcPts val="0"/>
+              </a:spcAft>
+              <a:buNone/>
+            </a:pPr>
+            <a:r>
+              <a:rPr b="1" lang="en" sz="1000"/>
+              <a:t>Default precision:</a:t>
+            </a:r>
+            <a:endParaRPr b="1" sz="1000"/>
+          </a:p>
+          <a:p>
+            <a:pPr indent="0" lvl="0" marL="0" rtl="0" algn="l">
+              <a:spcBef>
+                <a:spcPts val="0"/>
+              </a:spcBef>
+              <a:spcAft>
+                <a:spcPts val="0"/>
+              </a:spcAft>
+              <a:buNone/>
+            </a:pPr>
+            <a:r>
+              <a:rPr lang="en" sz="1000"/>
+              <a:t>Total execution time = 2.549 sec</a:t>
+            </a:r>
+            <a:endParaRPr sz="1000"/>
+          </a:p>
+          <a:p>
+            <a:pPr indent="0" lvl="0" marL="0" rtl="0" algn="l">
+              <a:spcBef>
+                <a:spcPts val="0"/>
+              </a:spcBef>
+              <a:spcAft>
+                <a:spcPts val="0"/>
+              </a:spcAft>
+              <a:buNone/>
+            </a:pPr>
+            <a:r>
+              <a:rPr lang="en" sz="1000"/>
+              <a:t>Max memory used by tensors = 2.78 GB</a:t>
+            </a:r>
+            <a:endParaRPr sz="1000"/>
+          </a:p>
+          <a:p>
+            <a:pPr indent="0" lvl="0" marL="0" rtl="0" algn="l">
+              <a:spcBef>
+                <a:spcPts val="0"/>
+              </a:spcBef>
+              <a:spcAft>
+                <a:spcPts val="0"/>
+              </a:spcAft>
+              <a:buNone/>
+            </a:pPr>
+            <a:r>
+              <a:t/>
+            </a:r>
+            <a:endParaRPr sz="1000"/>
+          </a:p>
+          <a:p>
+            <a:pPr indent="0" lvl="0" marL="0" rtl="0" algn="l">
+              <a:spcBef>
+                <a:spcPts val="0"/>
+              </a:spcBef>
+              <a:spcAft>
+                <a:spcPts val="0"/>
+              </a:spcAft>
+              <a:buNone/>
+            </a:pPr>
+            <a:r>
+              <a:rPr b="1" lang="en" sz="1000"/>
+              <a:t>Mixed precision:</a:t>
+            </a:r>
+            <a:endParaRPr b="1" sz="1000"/>
+          </a:p>
+          <a:p>
+            <a:pPr indent="0" lvl="0" marL="0" rtl="0" algn="l">
+              <a:spcBef>
+                <a:spcPts val="0"/>
+              </a:spcBef>
+              <a:spcAft>
+                <a:spcPts val="0"/>
+              </a:spcAft>
+              <a:buNone/>
+            </a:pPr>
+            <a:r>
+              <a:rPr lang="en" sz="1000"/>
+              <a:t>Total execution time = 1.354 sec</a:t>
+            </a:r>
+            <a:endParaRPr sz="1000"/>
+          </a:p>
+          <a:p>
+            <a:pPr indent="0" lvl="0" marL="0" rtl="0" algn="l">
+              <a:spcBef>
+                <a:spcPts val="0"/>
+              </a:spcBef>
+              <a:spcAft>
+                <a:spcPts val="0"/>
+              </a:spcAft>
+              <a:buNone/>
+            </a:pPr>
+            <a:r>
+              <a:rPr lang="en" sz="1000"/>
+              <a:t>Max memory used by tensors = 2.76 GB</a:t>
+            </a:r>
+            <a:endParaRPr sz="1000"/>
+          </a:p>
+        </p:txBody>
+      </p:sp>
+      <p:sp>
+        <p:nvSpPr>
+          <p:cNvPr id="244" name="Google Shape;244;p32"/>
+          <p:cNvSpPr txBox="1"/>
+          <p:nvPr/>
+        </p:nvSpPr>
+        <p:spPr>
+          <a:xfrm>
+            <a:off x="56425" y="4723350"/>
+            <a:ext cx="3000000" cy="338700"/>
+          </a:xfrm>
+          <a:prstGeom prst="rect">
+            <a:avLst/>
+          </a:prstGeom>
+          <a:noFill/>
+          <a:ln>
+            <a:noFill/>
+          </a:ln>
+        </p:spPr>
+        <p:txBody>
+          <a:bodyPr anchorCtr="0" anchor="t" bIns="91425" lIns="91425" spcFirstLastPara="1" rIns="91425" wrap="square" tIns="91425">
+            <a:spAutoFit/>
+          </a:bodyPr>
+          <a:lstStyle/>
+          <a:p>
+            <a:pPr indent="0" lvl="0" marL="0" rtl="0" algn="l">
+              <a:spcBef>
+                <a:spcPts val="0"/>
+              </a:spcBef>
+              <a:spcAft>
+                <a:spcPts val="0"/>
+              </a:spcAft>
+              <a:buNone/>
+            </a:pPr>
+            <a:r>
+              <a:rPr lang="en" sz="1000">
+                <a:solidFill>
+                  <a:schemeClr val="dk1"/>
+                </a:solidFill>
+              </a:rPr>
+              <a:t>full_vs_mixed_precision_timing.py</a:t>
+            </a:r>
+            <a:endParaRPr sz="1000">
+              <a:solidFill>
+                <a:srgbClr val="BCBEC4"/>
+              </a:solidFill>
+            </a:endParaRPr>
           </a:p>
         </p:txBody>
       </p:sp>
@@ -12617,6 +13083,285 @@
 </file>
 
 <file path=ppt/theme/theme1.xml><?xml version="1.0" encoding="utf-8"?>
+<a:theme xmlns:a="http://schemas.openxmlformats.org/drawingml/2006/main" xmlns:r="http://schemas.openxmlformats.org/officeDocument/2006/relationships">
+  <a:themeElements>
+    <a:clrScheme name="Default">
+      <a:dk1>
+        <a:srgbClr val="000000"/>
+      </a:dk1>
+      <a:lt1>
+        <a:srgbClr val="FFFFFF"/>
+      </a:lt1>
+      <a:dk2>
+        <a:srgbClr val="158158"/>
+      </a:dk2>
+      <a:lt2>
+        <a:srgbClr val="F3F3F3"/>
+      </a:lt2>
+      <a:accent1>
+        <a:srgbClr val="058DC7"/>
+      </a:accent1>
+      <a:accent2>
+        <a:srgbClr val="50B432"/>
+      </a:accent2>
+      <a:accent3>
+        <a:srgbClr val="ED561B"/>
+      </a:accent3>
+      <a:accent4>
+        <a:srgbClr val="EDEF00"/>
+      </a:accent4>
+      <a:accent5>
+        <a:srgbClr val="24CBE5"/>
+      </a:accent5>
+      <a:accent6>
+        <a:srgbClr val="64E572"/>
+      </a:accent6>
+      <a:hlink>
+        <a:srgbClr val="2200CC"/>
+      </a:hlink>
+      <a:folHlink>
+        <a:srgbClr val="551A8B"/>
+      </a:folHlink>
+    </a:clrScheme>
+    <a:fontScheme name="Office">
+      <a:majorFont>
+        <a:latin typeface="Arial"/>
+        <a:ea typeface=""/>
+        <a:cs typeface=""/>
+        <a:font script="Jpan" typeface="ＭＳ Ｐゴシック"/>
+        <a:font script="Hang" typeface="맑은 고딕"/>
+        <a:font script="Hans" typeface="宋体"/>
+        <a:font script="Hant" typeface="新細明體"/>
+        <a:font script="Arab" typeface="Times New Roman"/>
+        <a:font script="Hebr" typeface="Times New Roman"/>
+        <a:font script="Thai" typeface="Angsana New"/>
+        <a:font script="Ethi" typeface="Nyala"/>
+        <a:font script="Beng" typeface="Vrinda"/>
+        <a:font script="Gujr" typeface="Shruti"/>
+        <a:font script="Khmr" typeface="MoolBoran"/>
+        <a:font script="Knda" typeface="Tunga"/>
+        <a:font script="Guru" typeface="Raavi"/>
+        <a:font script="Cans" typeface="Euphemia"/>
+        <a:font script="Cher" typeface="Plantagenet Cherokee"/>
+        <a:font script="Yiii" typeface="Microsoft Yi Baiti"/>
+        <a:font script="Tibt" typeface="Microsoft Himalaya"/>
+        <a:font script="Thaa" typeface="MV Boli"/>
+        <a:font script="Deva" typeface="Mangal"/>
+        <a:font script="Telu" typeface="Gautami"/>
+        <a:font script="Taml" typeface="Latha"/>
+        <a:font script="Syrc" typeface="Estrangelo Edessa"/>
+        <a:font script="Orya" typeface="Kalinga"/>
+        <a:font script="Mlym" typeface="Kartika"/>
+        <a:font script="Laoo" typeface="DokChampa"/>
+        <a:font script="Sinh" typeface="Iskoola Pota"/>
+        <a:font script="Mong" typeface="Mongolian Baiti"/>
+        <a:font script="Viet" typeface="Times New Roman"/>
+        <a:font script="Uigh" typeface="Microsoft Uighur"/>
+        <a:font script="Geor" typeface="Sylfaen"/>
+      </a:majorFont>
+      <a:minorFont>
+        <a:latin typeface="Arial"/>
+        <a:ea typeface=""/>
+        <a:cs typeface=""/>
+        <a:font script="Jpan" typeface="ＭＳ Ｐゴシック"/>
+        <a:font script="Hang" typeface="맑은 고딕"/>
+        <a:font script="Hans" typeface="宋体"/>
+        <a:font script="Hant" typeface="新細明體"/>
+        <a:font script="Arab" typeface="Arial"/>
+        <a:font script="Hebr" typeface="Arial"/>
+        <a:font script="Thai" typeface="Cordia New"/>
+        <a:font script="Ethi" typeface="Nyala"/>
+        <a:font script="Beng" typeface="Vrinda"/>
+        <a:font script="Gujr" typeface="Shruti"/>
+        <a:font script="Khmr" typeface="DaunPenh"/>
+        <a:font script="Knda" typeface="Tunga"/>
+        <a:font script="Guru" typeface="Raavi"/>
+        <a:font script="Cans" typeface="Euphemia"/>
+        <a:font script="Cher" typeface="Plantagenet Cherokee"/>
+        <a:font script="Yiii" typeface="Microsoft Yi Baiti"/>
+        <a:font script="Tibt" typeface="Microsoft Himalaya"/>
+        <a:font script="Thaa" typeface="MV Boli"/>
+        <a:font script="Deva" typeface="Mangal"/>
+        <a:font script="Telu" typeface="Gautami"/>
+        <a:font script="Taml" typeface="Latha"/>
+        <a:font script="Syrc" typeface="Estrangelo Edessa"/>
+        <a:font script="Orya" typeface="Kalinga"/>
+        <a:font script="Mlym" typeface="Kartika"/>
+        <a:font script="Laoo" typeface="DokChampa"/>
+        <a:font script="Sinh" typeface="Iskoola Pota"/>
+        <a:font script="Mong" typeface="Mongolian Baiti"/>
+        <a:font script="Viet" typeface="Arial"/>
+        <a:font script="Uigh" typeface="Microsoft Uighur"/>
+        <a:font script="Geor" typeface="Sylfaen"/>
+      </a:minorFont>
+    </a:fontScheme>
+    <a:fmtScheme name="Office">
+      <a:fillStyleLst>
+        <a:solidFill>
+          <a:schemeClr val="phClr"/>
+        </a:solidFill>
+        <a:gradFill rotWithShape="1">
+          <a:gsLst>
+            <a:gs pos="0">
+              <a:schemeClr val="phClr">
+                <a:tint val="50000"/>
+                <a:satMod val="300000"/>
+              </a:schemeClr>
+            </a:gs>
+            <a:gs pos="35000">
+              <a:schemeClr val="phClr">
+                <a:tint val="37000"/>
+                <a:satMod val="300000"/>
+              </a:schemeClr>
+            </a:gs>
+            <a:gs pos="100000">
+              <a:schemeClr val="phClr">
+                <a:tint val="15000"/>
+                <a:satMod val="350000"/>
+              </a:schemeClr>
+            </a:gs>
+          </a:gsLst>
+          <a:lin ang="16200000" scaled="1"/>
+        </a:gradFill>
+        <a:gradFill rotWithShape="1">
+          <a:gsLst>
+            <a:gs pos="0">
+              <a:schemeClr val="phClr">
+                <a:tint val="100000"/>
+                <a:shade val="100000"/>
+                <a:satMod val="130000"/>
+              </a:schemeClr>
+            </a:gs>
+            <a:gs pos="100000">
+              <a:schemeClr val="phClr">
+                <a:tint val="50000"/>
+                <a:shade val="100000"/>
+                <a:satMod val="350000"/>
+              </a:schemeClr>
+            </a:gs>
+          </a:gsLst>
+          <a:lin ang="16200000" scaled="0"/>
+        </a:gradFill>
+      </a:fillStyleLst>
+      <a:lnStyleLst>
+        <a:ln w="9525" cap="flat" cmpd="sng" algn="ctr">
+          <a:solidFill>
+            <a:schemeClr val="phClr">
+              <a:shade val="95000"/>
+              <a:satMod val="105000"/>
+            </a:schemeClr>
+          </a:solidFill>
+          <a:prstDash val="solid"/>
+        </a:ln>
+        <a:ln w="25400" cap="flat" cmpd="sng" algn="ctr">
+          <a:solidFill>
+            <a:schemeClr val="phClr"/>
+          </a:solidFill>
+          <a:prstDash val="solid"/>
+        </a:ln>
+        <a:ln w="38100" cap="flat" cmpd="sng" algn="ctr">
+          <a:solidFill>
+            <a:schemeClr val="phClr"/>
+          </a:solidFill>
+          <a:prstDash val="solid"/>
+        </a:ln>
+      </a:lnStyleLst>
+      <a:effectStyleLst>
+        <a:effectStyle>
+          <a:effectLst>
+            <a:outerShdw blurRad="40000" dist="20000" dir="5400000" rotWithShape="0">
+              <a:srgbClr val="000000">
+                <a:alpha val="38000"/>
+              </a:srgbClr>
+            </a:outerShdw>
+          </a:effectLst>
+        </a:effectStyle>
+        <a:effectStyle>
+          <a:effectLst>
+            <a:outerShdw blurRad="40000" dist="23000" dir="5400000" rotWithShape="0">
+              <a:srgbClr val="000000">
+                <a:alpha val="35000"/>
+              </a:srgbClr>
+            </a:outerShdw>
+          </a:effectLst>
+        </a:effectStyle>
+        <a:effectStyle>
+          <a:effectLst>
+            <a:outerShdw blurRad="40000" dist="23000" dir="5400000" rotWithShape="0">
+              <a:srgbClr val="000000">
+                <a:alpha val="35000"/>
+              </a:srgbClr>
+            </a:outerShdw>
+          </a:effectLst>
+          <a:scene3d>
+            <a:camera prst="orthographicFront">
+              <a:rot lat="0" lon="0" rev="0"/>
+            </a:camera>
+            <a:lightRig rig="threePt" dir="t">
+              <a:rot lat="0" lon="0" rev="1200000"/>
+            </a:lightRig>
+          </a:scene3d>
+          <a:sp3d>
+            <a:bevelT w="63500" h="25400"/>
+          </a:sp3d>
+        </a:effectStyle>
+      </a:effectStyleLst>
+      <a:bgFillStyleLst>
+        <a:solidFill>
+          <a:schemeClr val="phClr"/>
+        </a:solidFill>
+        <a:gradFill rotWithShape="1">
+          <a:gsLst>
+            <a:gs pos="0">
+              <a:schemeClr val="phClr">
+                <a:tint val="40000"/>
+                <a:satMod val="350000"/>
+              </a:schemeClr>
+            </a:gs>
+            <a:gs pos="40000">
+              <a:schemeClr val="phClr">
+                <a:tint val="45000"/>
+                <a:shade val="99000"/>
+                <a:satMod val="350000"/>
+              </a:schemeClr>
+            </a:gs>
+            <a:gs pos="100000">
+              <a:schemeClr val="phClr">
+                <a:shade val="20000"/>
+                <a:satMod val="255000"/>
+              </a:schemeClr>
+            </a:gs>
+          </a:gsLst>
+          <a:path path="circle">
+            <a:fillToRect l="50000" t="-80000" r="50000" b="180000"/>
+          </a:path>
+        </a:gradFill>
+        <a:gradFill rotWithShape="1">
+          <a:gsLst>
+            <a:gs pos="0">
+              <a:schemeClr val="phClr">
+                <a:tint val="80000"/>
+                <a:satMod val="300000"/>
+              </a:schemeClr>
+            </a:gs>
+            <a:gs pos="100000">
+              <a:schemeClr val="phClr">
+                <a:shade val="30000"/>
+                <a:satMod val="200000"/>
+              </a:schemeClr>
+            </a:gs>
+          </a:gsLst>
+          <a:path path="circle">
+            <a:fillToRect l="50000" t="50000" r="50000" b="50000"/>
+          </a:path>
+        </a:gradFill>
+      </a:bgFillStyleLst>
+    </a:fmtScheme>
+  </a:themeElements>
+</a:theme>
+</file>
+
+<file path=ppt/theme/theme2.xml><?xml version="1.0" encoding="utf-8"?>
 <a:theme xmlns:a="http://schemas.openxmlformats.org/drawingml/2006/main" xmlns:r="http://schemas.openxmlformats.org/officeDocument/2006/relationships" name="Simple Light">
   <a:themeElements>
     <a:clrScheme name="Simple Light">
@@ -12893,283 +13638,4 @@
     </a:fmtScheme>
   </a:themeElements>
 </a:theme>
-</file>
-
-<file path=ppt/theme/theme2.xml><?xml version="1.0" encoding="utf-8"?>
-<a:theme xmlns:a="http://schemas.openxmlformats.org/drawingml/2006/main" xmlns:r="http://schemas.openxmlformats.org/officeDocument/2006/relationships">
-  <a:themeElements>
-    <a:clrScheme name="Default">
-      <a:dk1>
-        <a:srgbClr val="000000"/>
-      </a:dk1>
-      <a:lt1>
-        <a:srgbClr val="FFFFFF"/>
-      </a:lt1>
-      <a:dk2>
-        <a:srgbClr val="158158"/>
-      </a:dk2>
-      <a:lt2>
-        <a:srgbClr val="F3F3F3"/>
-      </a:lt2>
-      <a:accent1>
-        <a:srgbClr val="058DC7"/>
-      </a:accent1>
-      <a:accent2>
-        <a:srgbClr val="50B432"/>
-      </a:accent2>
-      <a:accent3>
-        <a:srgbClr val="ED561B"/>
-      </a:accent3>
-      <a:accent4>
-        <a:srgbClr val="EDEF00"/>
-      </a:accent4>
-      <a:accent5>
-        <a:srgbClr val="24CBE5"/>
-      </a:accent5>
-      <a:accent6>
-        <a:srgbClr val="64E572"/>
-      </a:accent6>
-      <a:hlink>
-        <a:srgbClr val="2200CC"/>
-      </a:hlink>
-      <a:folHlink>
-        <a:srgbClr val="551A8B"/>
-      </a:folHlink>
-    </a:clrScheme>
-    <a:fontScheme name="Office">
-      <a:majorFont>
-        <a:latin typeface="Arial"/>
-        <a:ea typeface=""/>
-        <a:cs typeface=""/>
-        <a:font script="Jpan" typeface="ＭＳ Ｐゴシック"/>
-        <a:font script="Hang" typeface="맑은 고딕"/>
-        <a:font script="Hans" typeface="宋体"/>
-        <a:font script="Hant" typeface="新細明體"/>
-        <a:font script="Arab" typeface="Times New Roman"/>
-        <a:font script="Hebr" typeface="Times New Roman"/>
-        <a:font script="Thai" typeface="Angsana New"/>
-        <a:font script="Ethi" typeface="Nyala"/>
-        <a:font script="Beng" typeface="Vrinda"/>
-        <a:font script="Gujr" typeface="Shruti"/>
-        <a:font script="Khmr" typeface="MoolBoran"/>
-        <a:font script="Knda" typeface="Tunga"/>
-        <a:font script="Guru" typeface="Raavi"/>
-        <a:font script="Cans" typeface="Euphemia"/>
-        <a:font script="Cher" typeface="Plantagenet Cherokee"/>
-        <a:font script="Yiii" typeface="Microsoft Yi Baiti"/>
-        <a:font script="Tibt" typeface="Microsoft Himalaya"/>
-        <a:font script="Thaa" typeface="MV Boli"/>
-        <a:font script="Deva" typeface="Mangal"/>
-        <a:font script="Telu" typeface="Gautami"/>
-        <a:font script="Taml" typeface="Latha"/>
-        <a:font script="Syrc" typeface="Estrangelo Edessa"/>
-        <a:font script="Orya" typeface="Kalinga"/>
-        <a:font script="Mlym" typeface="Kartika"/>
-        <a:font script="Laoo" typeface="DokChampa"/>
-        <a:font script="Sinh" typeface="Iskoola Pota"/>
-        <a:font script="Mong" typeface="Mongolian Baiti"/>
-        <a:font script="Viet" typeface="Times New Roman"/>
-        <a:font script="Uigh" typeface="Microsoft Uighur"/>
-        <a:font script="Geor" typeface="Sylfaen"/>
-      </a:majorFont>
-      <a:minorFont>
-        <a:latin typeface="Arial"/>
-        <a:ea typeface=""/>
-        <a:cs typeface=""/>
-        <a:font script="Jpan" typeface="ＭＳ Ｐゴシック"/>
-        <a:font script="Hang" typeface="맑은 고딕"/>
-        <a:font script="Hans" typeface="宋体"/>
-        <a:font script="Hant" typeface="新細明體"/>
-        <a:font script="Arab" typeface="Arial"/>
-        <a:font script="Hebr" typeface="Arial"/>
-        <a:font script="Thai" typeface="Cordia New"/>
-        <a:font script="Ethi" typeface="Nyala"/>
-        <a:font script="Beng" typeface="Vrinda"/>
-        <a:font script="Gujr" typeface="Shruti"/>
-        <a:font script="Khmr" typeface="DaunPenh"/>
-        <a:font script="Knda" typeface="Tunga"/>
-        <a:font script="Guru" typeface="Raavi"/>
-        <a:font script="Cans" typeface="Euphemia"/>
-        <a:font script="Cher" typeface="Plantagenet Cherokee"/>
-        <a:font script="Yiii" typeface="Microsoft Yi Baiti"/>
-        <a:font script="Tibt" typeface="Microsoft Himalaya"/>
-        <a:font script="Thaa" typeface="MV Boli"/>
-        <a:font script="Deva" typeface="Mangal"/>
-        <a:font script="Telu" typeface="Gautami"/>
-        <a:font script="Taml" typeface="Latha"/>
-        <a:font script="Syrc" typeface="Estrangelo Edessa"/>
-        <a:font script="Orya" typeface="Kalinga"/>
-        <a:font script="Mlym" typeface="Kartika"/>
-        <a:font script="Laoo" typeface="DokChampa"/>
-        <a:font script="Sinh" typeface="Iskoola Pota"/>
-        <a:font script="Mong" typeface="Mongolian Baiti"/>
-        <a:font script="Viet" typeface="Arial"/>
-        <a:font script="Uigh" typeface="Microsoft Uighur"/>
-        <a:font script="Geor" typeface="Sylfaen"/>
-      </a:minorFont>
-    </a:fontScheme>
-    <a:fmtScheme name="Office">
-      <a:fillStyleLst>
-        <a:solidFill>
-          <a:schemeClr val="phClr"/>
-        </a:solidFill>
-        <a:gradFill rotWithShape="1">
-          <a:gsLst>
-            <a:gs pos="0">
-              <a:schemeClr val="phClr">
-                <a:tint val="50000"/>
-                <a:satMod val="300000"/>
-              </a:schemeClr>
-            </a:gs>
-            <a:gs pos="35000">
-              <a:schemeClr val="phClr">
-                <a:tint val="37000"/>
-                <a:satMod val="300000"/>
-              </a:schemeClr>
-            </a:gs>
-            <a:gs pos="100000">
-              <a:schemeClr val="phClr">
-                <a:tint val="15000"/>
-                <a:satMod val="350000"/>
-              </a:schemeClr>
-            </a:gs>
-          </a:gsLst>
-          <a:lin ang="16200000" scaled="1"/>
-        </a:gradFill>
-        <a:gradFill rotWithShape="1">
-          <a:gsLst>
-            <a:gs pos="0">
-              <a:schemeClr val="phClr">
-                <a:tint val="100000"/>
-                <a:shade val="100000"/>
-                <a:satMod val="130000"/>
-              </a:schemeClr>
-            </a:gs>
-            <a:gs pos="100000">
-              <a:schemeClr val="phClr">
-                <a:tint val="50000"/>
-                <a:shade val="100000"/>
-                <a:satMod val="350000"/>
-              </a:schemeClr>
-            </a:gs>
-          </a:gsLst>
-          <a:lin ang="16200000" scaled="0"/>
-        </a:gradFill>
-      </a:fillStyleLst>
-      <a:lnStyleLst>
-        <a:ln w="9525" cap="flat" cmpd="sng" algn="ctr">
-          <a:solidFill>
-            <a:schemeClr val="phClr">
-              <a:shade val="95000"/>
-              <a:satMod val="105000"/>
-            </a:schemeClr>
-          </a:solidFill>
-          <a:prstDash val="solid"/>
-        </a:ln>
-        <a:ln w="25400" cap="flat" cmpd="sng" algn="ctr">
-          <a:solidFill>
-            <a:schemeClr val="phClr"/>
-          </a:solidFill>
-          <a:prstDash val="solid"/>
-        </a:ln>
-        <a:ln w="38100" cap="flat" cmpd="sng" algn="ctr">
-          <a:solidFill>
-            <a:schemeClr val="phClr"/>
-          </a:solidFill>
-          <a:prstDash val="solid"/>
-        </a:ln>
-      </a:lnStyleLst>
-      <a:effectStyleLst>
-        <a:effectStyle>
-          <a:effectLst>
-            <a:outerShdw blurRad="40000" dist="20000" dir="5400000" rotWithShape="0">
-              <a:srgbClr val="000000">
-                <a:alpha val="38000"/>
-              </a:srgbClr>
-            </a:outerShdw>
-          </a:effectLst>
-        </a:effectStyle>
-        <a:effectStyle>
-          <a:effectLst>
-            <a:outerShdw blurRad="40000" dist="23000" dir="5400000" rotWithShape="0">
-              <a:srgbClr val="000000">
-                <a:alpha val="35000"/>
-              </a:srgbClr>
-            </a:outerShdw>
-          </a:effectLst>
-        </a:effectStyle>
-        <a:effectStyle>
-          <a:effectLst>
-            <a:outerShdw blurRad="40000" dist="23000" dir="5400000" rotWithShape="0">
-              <a:srgbClr val="000000">
-                <a:alpha val="35000"/>
-              </a:srgbClr>
-            </a:outerShdw>
-          </a:effectLst>
-          <a:scene3d>
-            <a:camera prst="orthographicFront">
-              <a:rot lat="0" lon="0" rev="0"/>
-            </a:camera>
-            <a:lightRig rig="threePt" dir="t">
-              <a:rot lat="0" lon="0" rev="1200000"/>
-            </a:lightRig>
-          </a:scene3d>
-          <a:sp3d>
-            <a:bevelT w="63500" h="25400"/>
-          </a:sp3d>
-        </a:effectStyle>
-      </a:effectStyleLst>
-      <a:bgFillStyleLst>
-        <a:solidFill>
-          <a:schemeClr val="phClr"/>
-        </a:solidFill>
-        <a:gradFill rotWithShape="1">
-          <a:gsLst>
-            <a:gs pos="0">
-              <a:schemeClr val="phClr">
-                <a:tint val="40000"/>
-                <a:satMod val="350000"/>
-              </a:schemeClr>
-            </a:gs>
-            <a:gs pos="40000">
-              <a:schemeClr val="phClr">
-                <a:tint val="45000"/>
-                <a:shade val="99000"/>
-                <a:satMod val="350000"/>
-              </a:schemeClr>
-            </a:gs>
-            <a:gs pos="100000">
-              <a:schemeClr val="phClr">
-                <a:shade val="20000"/>
-                <a:satMod val="255000"/>
-              </a:schemeClr>
-            </a:gs>
-          </a:gsLst>
-          <a:path path="circle">
-            <a:fillToRect l="50000" t="-80000" r="50000" b="180000"/>
-          </a:path>
-        </a:gradFill>
-        <a:gradFill rotWithShape="1">
-          <a:gsLst>
-            <a:gs pos="0">
-              <a:schemeClr val="phClr">
-                <a:tint val="80000"/>
-                <a:satMod val="300000"/>
-              </a:schemeClr>
-            </a:gs>
-            <a:gs pos="100000">
-              <a:schemeClr val="phClr">
-                <a:shade val="30000"/>
-                <a:satMod val="200000"/>
-              </a:schemeClr>
-            </a:gs>
-          </a:gsLst>
-          <a:path path="circle">
-            <a:fillToRect l="50000" t="50000" r="50000" b="50000"/>
-          </a:path>
-        </a:gradFill>
-      </a:bgFillStyleLst>
-    </a:fmtScheme>
-  </a:themeElements>
-</a:theme>
 </file>
</xml_diff>